<commit_message>
PPD-9 unit test for master slide counts
</commit_message>
<xml_diff>
--- a/pptdiffer/src/test/resources/basicfiles/BasicFileE.pptx
+++ b/pptdiffer/src/test/resources/basicfiles/BasicFileE.pptx
@@ -3,11 +3,12 @@
 <p:presentation xmlns:a="http://schemas.openxmlformats.org/drawingml/2006/main" xmlns:r="http://schemas.openxmlformats.org/officeDocument/2006/relationships" xmlns:p="http://schemas.openxmlformats.org/presentationml/2006/main" saveSubsetFonts="1" autoCompressPictures="0">
   <p:sldMasterIdLst>
     <p:sldMasterId id="2147483648" r:id="rId1"/>
+    <p:sldMasterId id="2147483660" r:id="rId2"/>
   </p:sldMasterIdLst>
   <p:sldIdLst>
-    <p:sldId id="256" r:id="rId2"/>
-    <p:sldId id="257" r:id="rId3"/>
-    <p:sldId id="259" r:id="rId4"/>
+    <p:sldId id="256" r:id="rId3"/>
+    <p:sldId id="257" r:id="rId4"/>
+    <p:sldId id="259" r:id="rId5"/>
   </p:sldIdLst>
   <p:sldSz cx="12192000" cy="6858000"/>
   <p:notesSz cx="6858000" cy="9144000"/>
@@ -261,7 +262,7 @@
           <a:p>
             <a:fld id="{8F5F7886-6B74-6349-BE53-F5BA7B8ADE1D}" type="datetimeFigureOut">
               <a:rPr lang="en-US" smtClean="0"/>
-              <a:t>7/2/26</a:t>
+              <a:t>7/11/26</a:t>
             </a:fld>
             <a:endParaRPr lang="en-US"/>
           </a:p>
@@ -459,7 +460,7 @@
           <a:p>
             <a:fld id="{8F5F7886-6B74-6349-BE53-F5BA7B8ADE1D}" type="datetimeFigureOut">
               <a:rPr lang="en-US" smtClean="0"/>
-              <a:t>7/2/26</a:t>
+              <a:t>7/11/26</a:t>
             </a:fld>
             <a:endParaRPr lang="en-US"/>
           </a:p>
@@ -667,7 +668,7 @@
           <a:p>
             <a:fld id="{8F5F7886-6B74-6349-BE53-F5BA7B8ADE1D}" type="datetimeFigureOut">
               <a:rPr lang="en-US" smtClean="0"/>
-              <a:t>7/2/26</a:t>
+              <a:t>7/11/26</a:t>
             </a:fld>
             <a:endParaRPr lang="en-US"/>
           </a:p>
@@ -731,6 +732,1941 @@
     <p:extLst>
       <p:ext uri="{BB962C8B-B14F-4D97-AF65-F5344CB8AC3E}">
         <p14:creationId xmlns:p14="http://schemas.microsoft.com/office/powerpoint/2010/main" val="1487407413"/>
+      </p:ext>
+    </p:extLst>
+  </p:cSld>
+  <p:clrMapOvr>
+    <a:masterClrMapping/>
+  </p:clrMapOvr>
+</p:sldLayout>
+</file>
+
+<file path=ppt/slideLayouts/slideLayout12.xml><?xml version="1.0" encoding="utf-8"?>
+<p:sldLayout xmlns:a="http://schemas.openxmlformats.org/drawingml/2006/main" xmlns:r="http://schemas.openxmlformats.org/officeDocument/2006/relationships" xmlns:p="http://schemas.openxmlformats.org/presentationml/2006/main" type="title" preserve="1">
+  <p:cSld name="Title Slide">
+    <p:spTree>
+      <p:nvGrpSpPr>
+        <p:cNvPr id="1" name=""/>
+        <p:cNvGrpSpPr/>
+        <p:nvPr/>
+      </p:nvGrpSpPr>
+      <p:grpSpPr>
+        <a:xfrm>
+          <a:off x="0" y="0"/>
+          <a:ext cx="0" cy="0"/>
+          <a:chOff x="0" y="0"/>
+          <a:chExt cx="0" cy="0"/>
+        </a:xfrm>
+      </p:grpSpPr>
+      <p:sp>
+        <p:nvSpPr>
+          <p:cNvPr id="2" name="Title 1">
+            <a:extLst>
+              <a:ext uri="{FF2B5EF4-FFF2-40B4-BE49-F238E27FC236}">
+                <a16:creationId xmlns:a16="http://schemas.microsoft.com/office/drawing/2014/main" id="{F992BF3B-A26B-1F9F-6419-B2C8E40CE283}"/>
+              </a:ext>
+            </a:extLst>
+          </p:cNvPr>
+          <p:cNvSpPr>
+            <a:spLocks noGrp="1"/>
+          </p:cNvSpPr>
+          <p:nvPr>
+            <p:ph type="ctrTitle"/>
+          </p:nvPr>
+        </p:nvSpPr>
+        <p:spPr>
+          <a:xfrm>
+            <a:off x="1524000" y="1122363"/>
+            <a:ext cx="9144000" cy="2387600"/>
+          </a:xfrm>
+        </p:spPr>
+        <p:txBody>
+          <a:bodyPr anchor="b"/>
+          <a:lstStyle>
+            <a:lvl1pPr algn="ctr">
+              <a:defRPr sz="6000"/>
+            </a:lvl1pPr>
+          </a:lstStyle>
+          <a:p>
+            <a:r>
+              <a:rPr lang="en-US"/>
+              <a:t>Click to edit Master title style</a:t>
+            </a:r>
+          </a:p>
+        </p:txBody>
+      </p:sp>
+      <p:sp>
+        <p:nvSpPr>
+          <p:cNvPr id="3" name="Subtitle 2">
+            <a:extLst>
+              <a:ext uri="{FF2B5EF4-FFF2-40B4-BE49-F238E27FC236}">
+                <a16:creationId xmlns:a16="http://schemas.microsoft.com/office/drawing/2014/main" id="{822078D5-01BE-B0BA-BFD5-CDAB967AF8E3}"/>
+              </a:ext>
+            </a:extLst>
+          </p:cNvPr>
+          <p:cNvSpPr>
+            <a:spLocks noGrp="1"/>
+          </p:cNvSpPr>
+          <p:nvPr>
+            <p:ph type="subTitle" idx="1"/>
+          </p:nvPr>
+        </p:nvSpPr>
+        <p:spPr>
+          <a:xfrm>
+            <a:off x="1524000" y="3602038"/>
+            <a:ext cx="9144000" cy="1655762"/>
+          </a:xfrm>
+        </p:spPr>
+        <p:txBody>
+          <a:bodyPr/>
+          <a:lstStyle>
+            <a:lvl1pPr marL="0" indent="0" algn="ctr">
+              <a:buNone/>
+              <a:defRPr sz="2400"/>
+            </a:lvl1pPr>
+            <a:lvl2pPr marL="457200" indent="0" algn="ctr">
+              <a:buNone/>
+              <a:defRPr sz="2000"/>
+            </a:lvl2pPr>
+            <a:lvl3pPr marL="914400" indent="0" algn="ctr">
+              <a:buNone/>
+              <a:defRPr sz="1800"/>
+            </a:lvl3pPr>
+            <a:lvl4pPr marL="1371600" indent="0" algn="ctr">
+              <a:buNone/>
+              <a:defRPr sz="1600"/>
+            </a:lvl4pPr>
+            <a:lvl5pPr marL="1828800" indent="0" algn="ctr">
+              <a:buNone/>
+              <a:defRPr sz="1600"/>
+            </a:lvl5pPr>
+            <a:lvl6pPr marL="2286000" indent="0" algn="ctr">
+              <a:buNone/>
+              <a:defRPr sz="1600"/>
+            </a:lvl6pPr>
+            <a:lvl7pPr marL="2743200" indent="0" algn="ctr">
+              <a:buNone/>
+              <a:defRPr sz="1600"/>
+            </a:lvl7pPr>
+            <a:lvl8pPr marL="3200400" indent="0" algn="ctr">
+              <a:buNone/>
+              <a:defRPr sz="1600"/>
+            </a:lvl8pPr>
+            <a:lvl9pPr marL="3657600" indent="0" algn="ctr">
+              <a:buNone/>
+              <a:defRPr sz="1600"/>
+            </a:lvl9pPr>
+          </a:lstStyle>
+          <a:p>
+            <a:r>
+              <a:rPr lang="en-US"/>
+              <a:t>Click to edit Master subtitle style</a:t>
+            </a:r>
+          </a:p>
+        </p:txBody>
+      </p:sp>
+      <p:sp>
+        <p:nvSpPr>
+          <p:cNvPr id="4" name="Date Placeholder 3">
+            <a:extLst>
+              <a:ext uri="{FF2B5EF4-FFF2-40B4-BE49-F238E27FC236}">
+                <a16:creationId xmlns:a16="http://schemas.microsoft.com/office/drawing/2014/main" id="{52CADF47-2BD1-8913-5683-1B2D4CDE95B9}"/>
+              </a:ext>
+            </a:extLst>
+          </p:cNvPr>
+          <p:cNvSpPr>
+            <a:spLocks noGrp="1"/>
+          </p:cNvSpPr>
+          <p:nvPr>
+            <p:ph type="dt" sz="half" idx="10"/>
+          </p:nvPr>
+        </p:nvSpPr>
+        <p:spPr/>
+        <p:txBody>
+          <a:bodyPr/>
+          <a:lstStyle/>
+          <a:p>
+            <a:fld id="{9A7A563D-4F5F-0548-A50D-971717DDA77D}" type="datetimeFigureOut">
+              <a:rPr lang="en-US" smtClean="0"/>
+              <a:t>7/11/26</a:t>
+            </a:fld>
+            <a:endParaRPr lang="en-US"/>
+          </a:p>
+        </p:txBody>
+      </p:sp>
+      <p:sp>
+        <p:nvSpPr>
+          <p:cNvPr id="5" name="Footer Placeholder 4">
+            <a:extLst>
+              <a:ext uri="{FF2B5EF4-FFF2-40B4-BE49-F238E27FC236}">
+                <a16:creationId xmlns:a16="http://schemas.microsoft.com/office/drawing/2014/main" id="{52C074EF-4D8A-875A-0464-2FC37DBE7A18}"/>
+              </a:ext>
+            </a:extLst>
+          </p:cNvPr>
+          <p:cNvSpPr>
+            <a:spLocks noGrp="1"/>
+          </p:cNvSpPr>
+          <p:nvPr>
+            <p:ph type="ftr" sz="quarter" idx="11"/>
+          </p:nvPr>
+        </p:nvSpPr>
+        <p:spPr/>
+        <p:txBody>
+          <a:bodyPr/>
+          <a:lstStyle/>
+          <a:p>
+            <a:endParaRPr lang="en-US"/>
+          </a:p>
+        </p:txBody>
+      </p:sp>
+      <p:sp>
+        <p:nvSpPr>
+          <p:cNvPr id="6" name="Slide Number Placeholder 5">
+            <a:extLst>
+              <a:ext uri="{FF2B5EF4-FFF2-40B4-BE49-F238E27FC236}">
+                <a16:creationId xmlns:a16="http://schemas.microsoft.com/office/drawing/2014/main" id="{B6AE11C3-5505-A01A-444F-CA74E1C80512}"/>
+              </a:ext>
+            </a:extLst>
+          </p:cNvPr>
+          <p:cNvSpPr>
+            <a:spLocks noGrp="1"/>
+          </p:cNvSpPr>
+          <p:nvPr>
+            <p:ph type="sldNum" sz="quarter" idx="12"/>
+          </p:nvPr>
+        </p:nvSpPr>
+        <p:spPr/>
+        <p:txBody>
+          <a:bodyPr/>
+          <a:lstStyle/>
+          <a:p>
+            <a:fld id="{4F4A9865-8A1B-3947-85F2-6D3624F4EFBD}" type="slidenum">
+              <a:rPr lang="en-US" smtClean="0"/>
+              <a:t>‹#›</a:t>
+            </a:fld>
+            <a:endParaRPr lang="en-US"/>
+          </a:p>
+        </p:txBody>
+      </p:sp>
+    </p:spTree>
+    <p:extLst>
+      <p:ext uri="{BB962C8B-B14F-4D97-AF65-F5344CB8AC3E}">
+        <p14:creationId xmlns:p14="http://schemas.microsoft.com/office/powerpoint/2010/main" val="3465541398"/>
+      </p:ext>
+    </p:extLst>
+  </p:cSld>
+  <p:clrMapOvr>
+    <a:masterClrMapping/>
+  </p:clrMapOvr>
+</p:sldLayout>
+</file>
+
+<file path=ppt/slideLayouts/slideLayout13.xml><?xml version="1.0" encoding="utf-8"?>
+<p:sldLayout xmlns:a="http://schemas.openxmlformats.org/drawingml/2006/main" xmlns:r="http://schemas.openxmlformats.org/officeDocument/2006/relationships" xmlns:p="http://schemas.openxmlformats.org/presentationml/2006/main" type="obj" preserve="1">
+  <p:cSld name="Title and Content">
+    <p:spTree>
+      <p:nvGrpSpPr>
+        <p:cNvPr id="1" name=""/>
+        <p:cNvGrpSpPr/>
+        <p:nvPr/>
+      </p:nvGrpSpPr>
+      <p:grpSpPr>
+        <a:xfrm>
+          <a:off x="0" y="0"/>
+          <a:ext cx="0" cy="0"/>
+          <a:chOff x="0" y="0"/>
+          <a:chExt cx="0" cy="0"/>
+        </a:xfrm>
+      </p:grpSpPr>
+      <p:sp>
+        <p:nvSpPr>
+          <p:cNvPr id="2" name="Title 1">
+            <a:extLst>
+              <a:ext uri="{FF2B5EF4-FFF2-40B4-BE49-F238E27FC236}">
+                <a16:creationId xmlns:a16="http://schemas.microsoft.com/office/drawing/2014/main" id="{FEF393BB-C2C0-0DD6-0375-C2935B8FA72C}"/>
+              </a:ext>
+            </a:extLst>
+          </p:cNvPr>
+          <p:cNvSpPr>
+            <a:spLocks noGrp="1"/>
+          </p:cNvSpPr>
+          <p:nvPr>
+            <p:ph type="title"/>
+          </p:nvPr>
+        </p:nvSpPr>
+        <p:spPr/>
+        <p:txBody>
+          <a:bodyPr/>
+          <a:lstStyle/>
+          <a:p>
+            <a:r>
+              <a:rPr lang="en-US"/>
+              <a:t>Click to edit Master title style</a:t>
+            </a:r>
+          </a:p>
+        </p:txBody>
+      </p:sp>
+      <p:sp>
+        <p:nvSpPr>
+          <p:cNvPr id="3" name="Content Placeholder 2">
+            <a:extLst>
+              <a:ext uri="{FF2B5EF4-FFF2-40B4-BE49-F238E27FC236}">
+                <a16:creationId xmlns:a16="http://schemas.microsoft.com/office/drawing/2014/main" id="{F761C252-BAED-AAD3-267B-AFBE4062B05F}"/>
+              </a:ext>
+            </a:extLst>
+          </p:cNvPr>
+          <p:cNvSpPr>
+            <a:spLocks noGrp="1"/>
+          </p:cNvSpPr>
+          <p:nvPr>
+            <p:ph idx="1"/>
+          </p:nvPr>
+        </p:nvSpPr>
+        <p:spPr/>
+        <p:txBody>
+          <a:bodyPr/>
+          <a:lstStyle/>
+          <a:p>
+            <a:pPr lvl="0"/>
+            <a:r>
+              <a:rPr lang="en-US"/>
+              <a:t>Click to edit Master text styles</a:t>
+            </a:r>
+          </a:p>
+          <a:p>
+            <a:pPr lvl="1"/>
+            <a:r>
+              <a:rPr lang="en-US"/>
+              <a:t>Second level</a:t>
+            </a:r>
+          </a:p>
+          <a:p>
+            <a:pPr lvl="2"/>
+            <a:r>
+              <a:rPr lang="en-US"/>
+              <a:t>Third level</a:t>
+            </a:r>
+          </a:p>
+          <a:p>
+            <a:pPr lvl="3"/>
+            <a:r>
+              <a:rPr lang="en-US"/>
+              <a:t>Fourth level</a:t>
+            </a:r>
+          </a:p>
+          <a:p>
+            <a:pPr lvl="4"/>
+            <a:r>
+              <a:rPr lang="en-US"/>
+              <a:t>Fifth level</a:t>
+            </a:r>
+          </a:p>
+        </p:txBody>
+      </p:sp>
+      <p:sp>
+        <p:nvSpPr>
+          <p:cNvPr id="4" name="Date Placeholder 3">
+            <a:extLst>
+              <a:ext uri="{FF2B5EF4-FFF2-40B4-BE49-F238E27FC236}">
+                <a16:creationId xmlns:a16="http://schemas.microsoft.com/office/drawing/2014/main" id="{C7E8617C-C449-ECD9-B950-EEEF4504BABD}"/>
+              </a:ext>
+            </a:extLst>
+          </p:cNvPr>
+          <p:cNvSpPr>
+            <a:spLocks noGrp="1"/>
+          </p:cNvSpPr>
+          <p:nvPr>
+            <p:ph type="dt" sz="half" idx="10"/>
+          </p:nvPr>
+        </p:nvSpPr>
+        <p:spPr/>
+        <p:txBody>
+          <a:bodyPr/>
+          <a:lstStyle/>
+          <a:p>
+            <a:fld id="{9A7A563D-4F5F-0548-A50D-971717DDA77D}" type="datetimeFigureOut">
+              <a:rPr lang="en-US" smtClean="0"/>
+              <a:t>7/11/26</a:t>
+            </a:fld>
+            <a:endParaRPr lang="en-US"/>
+          </a:p>
+        </p:txBody>
+      </p:sp>
+      <p:sp>
+        <p:nvSpPr>
+          <p:cNvPr id="5" name="Footer Placeholder 4">
+            <a:extLst>
+              <a:ext uri="{FF2B5EF4-FFF2-40B4-BE49-F238E27FC236}">
+                <a16:creationId xmlns:a16="http://schemas.microsoft.com/office/drawing/2014/main" id="{26A8ADBF-CA3E-3A02-AD60-E69B3B21B2C2}"/>
+              </a:ext>
+            </a:extLst>
+          </p:cNvPr>
+          <p:cNvSpPr>
+            <a:spLocks noGrp="1"/>
+          </p:cNvSpPr>
+          <p:nvPr>
+            <p:ph type="ftr" sz="quarter" idx="11"/>
+          </p:nvPr>
+        </p:nvSpPr>
+        <p:spPr/>
+        <p:txBody>
+          <a:bodyPr/>
+          <a:lstStyle/>
+          <a:p>
+            <a:endParaRPr lang="en-US"/>
+          </a:p>
+        </p:txBody>
+      </p:sp>
+      <p:sp>
+        <p:nvSpPr>
+          <p:cNvPr id="6" name="Slide Number Placeholder 5">
+            <a:extLst>
+              <a:ext uri="{FF2B5EF4-FFF2-40B4-BE49-F238E27FC236}">
+                <a16:creationId xmlns:a16="http://schemas.microsoft.com/office/drawing/2014/main" id="{7311C0DD-E18D-35AD-E6C9-41CC5A0D8357}"/>
+              </a:ext>
+            </a:extLst>
+          </p:cNvPr>
+          <p:cNvSpPr>
+            <a:spLocks noGrp="1"/>
+          </p:cNvSpPr>
+          <p:nvPr>
+            <p:ph type="sldNum" sz="quarter" idx="12"/>
+          </p:nvPr>
+        </p:nvSpPr>
+        <p:spPr/>
+        <p:txBody>
+          <a:bodyPr/>
+          <a:lstStyle/>
+          <a:p>
+            <a:fld id="{4F4A9865-8A1B-3947-85F2-6D3624F4EFBD}" type="slidenum">
+              <a:rPr lang="en-US" smtClean="0"/>
+              <a:t>‹#›</a:t>
+            </a:fld>
+            <a:endParaRPr lang="en-US"/>
+          </a:p>
+        </p:txBody>
+      </p:sp>
+    </p:spTree>
+    <p:extLst>
+      <p:ext uri="{BB962C8B-B14F-4D97-AF65-F5344CB8AC3E}">
+        <p14:creationId xmlns:p14="http://schemas.microsoft.com/office/powerpoint/2010/main" val="1859664621"/>
+      </p:ext>
+    </p:extLst>
+  </p:cSld>
+  <p:clrMapOvr>
+    <a:masterClrMapping/>
+  </p:clrMapOvr>
+</p:sldLayout>
+</file>
+
+<file path=ppt/slideLayouts/slideLayout14.xml><?xml version="1.0" encoding="utf-8"?>
+<p:sldLayout xmlns:a="http://schemas.openxmlformats.org/drawingml/2006/main" xmlns:r="http://schemas.openxmlformats.org/officeDocument/2006/relationships" xmlns:p="http://schemas.openxmlformats.org/presentationml/2006/main" type="secHead" preserve="1">
+  <p:cSld name="Section Header">
+    <p:spTree>
+      <p:nvGrpSpPr>
+        <p:cNvPr id="1" name=""/>
+        <p:cNvGrpSpPr/>
+        <p:nvPr/>
+      </p:nvGrpSpPr>
+      <p:grpSpPr>
+        <a:xfrm>
+          <a:off x="0" y="0"/>
+          <a:ext cx="0" cy="0"/>
+          <a:chOff x="0" y="0"/>
+          <a:chExt cx="0" cy="0"/>
+        </a:xfrm>
+      </p:grpSpPr>
+      <p:sp>
+        <p:nvSpPr>
+          <p:cNvPr id="2" name="Title 1">
+            <a:extLst>
+              <a:ext uri="{FF2B5EF4-FFF2-40B4-BE49-F238E27FC236}">
+                <a16:creationId xmlns:a16="http://schemas.microsoft.com/office/drawing/2014/main" id="{05601BBF-5750-AB25-9325-BDC5ABCD72BC}"/>
+              </a:ext>
+            </a:extLst>
+          </p:cNvPr>
+          <p:cNvSpPr>
+            <a:spLocks noGrp="1"/>
+          </p:cNvSpPr>
+          <p:nvPr>
+            <p:ph type="title"/>
+          </p:nvPr>
+        </p:nvSpPr>
+        <p:spPr>
+          <a:xfrm>
+            <a:off x="831850" y="1709738"/>
+            <a:ext cx="10515600" cy="2852737"/>
+          </a:xfrm>
+        </p:spPr>
+        <p:txBody>
+          <a:bodyPr anchor="b"/>
+          <a:lstStyle>
+            <a:lvl1pPr>
+              <a:defRPr sz="6000"/>
+            </a:lvl1pPr>
+          </a:lstStyle>
+          <a:p>
+            <a:r>
+              <a:rPr lang="en-US"/>
+              <a:t>Click to edit Master title style</a:t>
+            </a:r>
+          </a:p>
+        </p:txBody>
+      </p:sp>
+      <p:sp>
+        <p:nvSpPr>
+          <p:cNvPr id="3" name="Text Placeholder 2">
+            <a:extLst>
+              <a:ext uri="{FF2B5EF4-FFF2-40B4-BE49-F238E27FC236}">
+                <a16:creationId xmlns:a16="http://schemas.microsoft.com/office/drawing/2014/main" id="{C57559BC-D31A-1E12-966B-2F77F7CB6A82}"/>
+              </a:ext>
+            </a:extLst>
+          </p:cNvPr>
+          <p:cNvSpPr>
+            <a:spLocks noGrp="1"/>
+          </p:cNvSpPr>
+          <p:nvPr>
+            <p:ph type="body" idx="1"/>
+          </p:nvPr>
+        </p:nvSpPr>
+        <p:spPr>
+          <a:xfrm>
+            <a:off x="831850" y="4589463"/>
+            <a:ext cx="10515600" cy="1500187"/>
+          </a:xfrm>
+        </p:spPr>
+        <p:txBody>
+          <a:bodyPr/>
+          <a:lstStyle>
+            <a:lvl1pPr marL="0" indent="0">
+              <a:buNone/>
+              <a:defRPr sz="2400">
+                <a:solidFill>
+                  <a:schemeClr val="tx1">
+                    <a:tint val="82000"/>
+                  </a:schemeClr>
+                </a:solidFill>
+              </a:defRPr>
+            </a:lvl1pPr>
+            <a:lvl2pPr marL="457200" indent="0">
+              <a:buNone/>
+              <a:defRPr sz="2000">
+                <a:solidFill>
+                  <a:schemeClr val="tx1">
+                    <a:tint val="82000"/>
+                  </a:schemeClr>
+                </a:solidFill>
+              </a:defRPr>
+            </a:lvl2pPr>
+            <a:lvl3pPr marL="914400" indent="0">
+              <a:buNone/>
+              <a:defRPr sz="1800">
+                <a:solidFill>
+                  <a:schemeClr val="tx1">
+                    <a:tint val="82000"/>
+                  </a:schemeClr>
+                </a:solidFill>
+              </a:defRPr>
+            </a:lvl3pPr>
+            <a:lvl4pPr marL="1371600" indent="0">
+              <a:buNone/>
+              <a:defRPr sz="1600">
+                <a:solidFill>
+                  <a:schemeClr val="tx1">
+                    <a:tint val="82000"/>
+                  </a:schemeClr>
+                </a:solidFill>
+              </a:defRPr>
+            </a:lvl4pPr>
+            <a:lvl5pPr marL="1828800" indent="0">
+              <a:buNone/>
+              <a:defRPr sz="1600">
+                <a:solidFill>
+                  <a:schemeClr val="tx1">
+                    <a:tint val="82000"/>
+                  </a:schemeClr>
+                </a:solidFill>
+              </a:defRPr>
+            </a:lvl5pPr>
+            <a:lvl6pPr marL="2286000" indent="0">
+              <a:buNone/>
+              <a:defRPr sz="1600">
+                <a:solidFill>
+                  <a:schemeClr val="tx1">
+                    <a:tint val="82000"/>
+                  </a:schemeClr>
+                </a:solidFill>
+              </a:defRPr>
+            </a:lvl6pPr>
+            <a:lvl7pPr marL="2743200" indent="0">
+              <a:buNone/>
+              <a:defRPr sz="1600">
+                <a:solidFill>
+                  <a:schemeClr val="tx1">
+                    <a:tint val="82000"/>
+                  </a:schemeClr>
+                </a:solidFill>
+              </a:defRPr>
+            </a:lvl7pPr>
+            <a:lvl8pPr marL="3200400" indent="0">
+              <a:buNone/>
+              <a:defRPr sz="1600">
+                <a:solidFill>
+                  <a:schemeClr val="tx1">
+                    <a:tint val="82000"/>
+                  </a:schemeClr>
+                </a:solidFill>
+              </a:defRPr>
+            </a:lvl8pPr>
+            <a:lvl9pPr marL="3657600" indent="0">
+              <a:buNone/>
+              <a:defRPr sz="1600">
+                <a:solidFill>
+                  <a:schemeClr val="tx1">
+                    <a:tint val="82000"/>
+                  </a:schemeClr>
+                </a:solidFill>
+              </a:defRPr>
+            </a:lvl9pPr>
+          </a:lstStyle>
+          <a:p>
+            <a:pPr lvl="0"/>
+            <a:r>
+              <a:rPr lang="en-US"/>
+              <a:t>Click to edit Master text styles</a:t>
+            </a:r>
+          </a:p>
+        </p:txBody>
+      </p:sp>
+      <p:sp>
+        <p:nvSpPr>
+          <p:cNvPr id="4" name="Date Placeholder 3">
+            <a:extLst>
+              <a:ext uri="{FF2B5EF4-FFF2-40B4-BE49-F238E27FC236}">
+                <a16:creationId xmlns:a16="http://schemas.microsoft.com/office/drawing/2014/main" id="{E6E0DD1B-7313-D52D-8593-A010246F22A2}"/>
+              </a:ext>
+            </a:extLst>
+          </p:cNvPr>
+          <p:cNvSpPr>
+            <a:spLocks noGrp="1"/>
+          </p:cNvSpPr>
+          <p:nvPr>
+            <p:ph type="dt" sz="half" idx="10"/>
+          </p:nvPr>
+        </p:nvSpPr>
+        <p:spPr/>
+        <p:txBody>
+          <a:bodyPr/>
+          <a:lstStyle/>
+          <a:p>
+            <a:fld id="{9A7A563D-4F5F-0548-A50D-971717DDA77D}" type="datetimeFigureOut">
+              <a:rPr lang="en-US" smtClean="0"/>
+              <a:t>7/11/26</a:t>
+            </a:fld>
+            <a:endParaRPr lang="en-US"/>
+          </a:p>
+        </p:txBody>
+      </p:sp>
+      <p:sp>
+        <p:nvSpPr>
+          <p:cNvPr id="5" name="Footer Placeholder 4">
+            <a:extLst>
+              <a:ext uri="{FF2B5EF4-FFF2-40B4-BE49-F238E27FC236}">
+                <a16:creationId xmlns:a16="http://schemas.microsoft.com/office/drawing/2014/main" id="{78258C87-3988-5EF1-6F32-3322A8FCD17F}"/>
+              </a:ext>
+            </a:extLst>
+          </p:cNvPr>
+          <p:cNvSpPr>
+            <a:spLocks noGrp="1"/>
+          </p:cNvSpPr>
+          <p:nvPr>
+            <p:ph type="ftr" sz="quarter" idx="11"/>
+          </p:nvPr>
+        </p:nvSpPr>
+        <p:spPr/>
+        <p:txBody>
+          <a:bodyPr/>
+          <a:lstStyle/>
+          <a:p>
+            <a:endParaRPr lang="en-US"/>
+          </a:p>
+        </p:txBody>
+      </p:sp>
+      <p:sp>
+        <p:nvSpPr>
+          <p:cNvPr id="6" name="Slide Number Placeholder 5">
+            <a:extLst>
+              <a:ext uri="{FF2B5EF4-FFF2-40B4-BE49-F238E27FC236}">
+                <a16:creationId xmlns:a16="http://schemas.microsoft.com/office/drawing/2014/main" id="{03A4EA64-26AE-B7BB-D55A-4BD40A6AF979}"/>
+              </a:ext>
+            </a:extLst>
+          </p:cNvPr>
+          <p:cNvSpPr>
+            <a:spLocks noGrp="1"/>
+          </p:cNvSpPr>
+          <p:nvPr>
+            <p:ph type="sldNum" sz="quarter" idx="12"/>
+          </p:nvPr>
+        </p:nvSpPr>
+        <p:spPr/>
+        <p:txBody>
+          <a:bodyPr/>
+          <a:lstStyle/>
+          <a:p>
+            <a:fld id="{4F4A9865-8A1B-3947-85F2-6D3624F4EFBD}" type="slidenum">
+              <a:rPr lang="en-US" smtClean="0"/>
+              <a:t>‹#›</a:t>
+            </a:fld>
+            <a:endParaRPr lang="en-US"/>
+          </a:p>
+        </p:txBody>
+      </p:sp>
+    </p:spTree>
+    <p:extLst>
+      <p:ext uri="{BB962C8B-B14F-4D97-AF65-F5344CB8AC3E}">
+        <p14:creationId xmlns:p14="http://schemas.microsoft.com/office/powerpoint/2010/main" val="2199659815"/>
+      </p:ext>
+    </p:extLst>
+  </p:cSld>
+  <p:clrMapOvr>
+    <a:masterClrMapping/>
+  </p:clrMapOvr>
+</p:sldLayout>
+</file>
+
+<file path=ppt/slideLayouts/slideLayout15.xml><?xml version="1.0" encoding="utf-8"?>
+<p:sldLayout xmlns:a="http://schemas.openxmlformats.org/drawingml/2006/main" xmlns:r="http://schemas.openxmlformats.org/officeDocument/2006/relationships" xmlns:p="http://schemas.openxmlformats.org/presentationml/2006/main" type="twoObj" preserve="1">
+  <p:cSld name="Two Content">
+    <p:spTree>
+      <p:nvGrpSpPr>
+        <p:cNvPr id="1" name=""/>
+        <p:cNvGrpSpPr/>
+        <p:nvPr/>
+      </p:nvGrpSpPr>
+      <p:grpSpPr>
+        <a:xfrm>
+          <a:off x="0" y="0"/>
+          <a:ext cx="0" cy="0"/>
+          <a:chOff x="0" y="0"/>
+          <a:chExt cx="0" cy="0"/>
+        </a:xfrm>
+      </p:grpSpPr>
+      <p:sp>
+        <p:nvSpPr>
+          <p:cNvPr id="2" name="Title 1">
+            <a:extLst>
+              <a:ext uri="{FF2B5EF4-FFF2-40B4-BE49-F238E27FC236}">
+                <a16:creationId xmlns:a16="http://schemas.microsoft.com/office/drawing/2014/main" id="{C8F683E2-30F5-2A46-93F0-1852D95CF16E}"/>
+              </a:ext>
+            </a:extLst>
+          </p:cNvPr>
+          <p:cNvSpPr>
+            <a:spLocks noGrp="1"/>
+          </p:cNvSpPr>
+          <p:nvPr>
+            <p:ph type="title"/>
+          </p:nvPr>
+        </p:nvSpPr>
+        <p:spPr/>
+        <p:txBody>
+          <a:bodyPr/>
+          <a:lstStyle/>
+          <a:p>
+            <a:r>
+              <a:rPr lang="en-US"/>
+              <a:t>Click to edit Master title style</a:t>
+            </a:r>
+          </a:p>
+        </p:txBody>
+      </p:sp>
+      <p:sp>
+        <p:nvSpPr>
+          <p:cNvPr id="3" name="Content Placeholder 2">
+            <a:extLst>
+              <a:ext uri="{FF2B5EF4-FFF2-40B4-BE49-F238E27FC236}">
+                <a16:creationId xmlns:a16="http://schemas.microsoft.com/office/drawing/2014/main" id="{D27CCEE6-CB45-6796-F4DF-D37A66D197C4}"/>
+              </a:ext>
+            </a:extLst>
+          </p:cNvPr>
+          <p:cNvSpPr>
+            <a:spLocks noGrp="1"/>
+          </p:cNvSpPr>
+          <p:nvPr>
+            <p:ph sz="half" idx="1"/>
+          </p:nvPr>
+        </p:nvSpPr>
+        <p:spPr>
+          <a:xfrm>
+            <a:off x="838200" y="1825625"/>
+            <a:ext cx="5181600" cy="4351338"/>
+          </a:xfrm>
+        </p:spPr>
+        <p:txBody>
+          <a:bodyPr/>
+          <a:lstStyle/>
+          <a:p>
+            <a:pPr lvl="0"/>
+            <a:r>
+              <a:rPr lang="en-US"/>
+              <a:t>Click to edit Master text styles</a:t>
+            </a:r>
+          </a:p>
+          <a:p>
+            <a:pPr lvl="1"/>
+            <a:r>
+              <a:rPr lang="en-US"/>
+              <a:t>Second level</a:t>
+            </a:r>
+          </a:p>
+          <a:p>
+            <a:pPr lvl="2"/>
+            <a:r>
+              <a:rPr lang="en-US"/>
+              <a:t>Third level</a:t>
+            </a:r>
+          </a:p>
+          <a:p>
+            <a:pPr lvl="3"/>
+            <a:r>
+              <a:rPr lang="en-US"/>
+              <a:t>Fourth level</a:t>
+            </a:r>
+          </a:p>
+          <a:p>
+            <a:pPr lvl="4"/>
+            <a:r>
+              <a:rPr lang="en-US"/>
+              <a:t>Fifth level</a:t>
+            </a:r>
+          </a:p>
+        </p:txBody>
+      </p:sp>
+      <p:sp>
+        <p:nvSpPr>
+          <p:cNvPr id="4" name="Content Placeholder 3">
+            <a:extLst>
+              <a:ext uri="{FF2B5EF4-FFF2-40B4-BE49-F238E27FC236}">
+                <a16:creationId xmlns:a16="http://schemas.microsoft.com/office/drawing/2014/main" id="{85F60BF8-0BD6-FF49-B1CD-8B4406461522}"/>
+              </a:ext>
+            </a:extLst>
+          </p:cNvPr>
+          <p:cNvSpPr>
+            <a:spLocks noGrp="1"/>
+          </p:cNvSpPr>
+          <p:nvPr>
+            <p:ph sz="half" idx="2"/>
+          </p:nvPr>
+        </p:nvSpPr>
+        <p:spPr>
+          <a:xfrm>
+            <a:off x="6172200" y="1825625"/>
+            <a:ext cx="5181600" cy="4351338"/>
+          </a:xfrm>
+        </p:spPr>
+        <p:txBody>
+          <a:bodyPr/>
+          <a:lstStyle/>
+          <a:p>
+            <a:pPr lvl="0"/>
+            <a:r>
+              <a:rPr lang="en-US"/>
+              <a:t>Click to edit Master text styles</a:t>
+            </a:r>
+          </a:p>
+          <a:p>
+            <a:pPr lvl="1"/>
+            <a:r>
+              <a:rPr lang="en-US"/>
+              <a:t>Second level</a:t>
+            </a:r>
+          </a:p>
+          <a:p>
+            <a:pPr lvl="2"/>
+            <a:r>
+              <a:rPr lang="en-US"/>
+              <a:t>Third level</a:t>
+            </a:r>
+          </a:p>
+          <a:p>
+            <a:pPr lvl="3"/>
+            <a:r>
+              <a:rPr lang="en-US"/>
+              <a:t>Fourth level</a:t>
+            </a:r>
+          </a:p>
+          <a:p>
+            <a:pPr lvl="4"/>
+            <a:r>
+              <a:rPr lang="en-US"/>
+              <a:t>Fifth level</a:t>
+            </a:r>
+          </a:p>
+        </p:txBody>
+      </p:sp>
+      <p:sp>
+        <p:nvSpPr>
+          <p:cNvPr id="5" name="Date Placeholder 4">
+            <a:extLst>
+              <a:ext uri="{FF2B5EF4-FFF2-40B4-BE49-F238E27FC236}">
+                <a16:creationId xmlns:a16="http://schemas.microsoft.com/office/drawing/2014/main" id="{45DFE730-E8D7-A258-F55B-5E4C962FC8DE}"/>
+              </a:ext>
+            </a:extLst>
+          </p:cNvPr>
+          <p:cNvSpPr>
+            <a:spLocks noGrp="1"/>
+          </p:cNvSpPr>
+          <p:nvPr>
+            <p:ph type="dt" sz="half" idx="10"/>
+          </p:nvPr>
+        </p:nvSpPr>
+        <p:spPr/>
+        <p:txBody>
+          <a:bodyPr/>
+          <a:lstStyle/>
+          <a:p>
+            <a:fld id="{9A7A563D-4F5F-0548-A50D-971717DDA77D}" type="datetimeFigureOut">
+              <a:rPr lang="en-US" smtClean="0"/>
+              <a:t>7/11/26</a:t>
+            </a:fld>
+            <a:endParaRPr lang="en-US"/>
+          </a:p>
+        </p:txBody>
+      </p:sp>
+      <p:sp>
+        <p:nvSpPr>
+          <p:cNvPr id="6" name="Footer Placeholder 5">
+            <a:extLst>
+              <a:ext uri="{FF2B5EF4-FFF2-40B4-BE49-F238E27FC236}">
+                <a16:creationId xmlns:a16="http://schemas.microsoft.com/office/drawing/2014/main" id="{3D8D37D5-3D2C-C89D-3F86-9F3BC596FC4E}"/>
+              </a:ext>
+            </a:extLst>
+          </p:cNvPr>
+          <p:cNvSpPr>
+            <a:spLocks noGrp="1"/>
+          </p:cNvSpPr>
+          <p:nvPr>
+            <p:ph type="ftr" sz="quarter" idx="11"/>
+          </p:nvPr>
+        </p:nvSpPr>
+        <p:spPr/>
+        <p:txBody>
+          <a:bodyPr/>
+          <a:lstStyle/>
+          <a:p>
+            <a:endParaRPr lang="en-US"/>
+          </a:p>
+        </p:txBody>
+      </p:sp>
+      <p:sp>
+        <p:nvSpPr>
+          <p:cNvPr id="7" name="Slide Number Placeholder 6">
+            <a:extLst>
+              <a:ext uri="{FF2B5EF4-FFF2-40B4-BE49-F238E27FC236}">
+                <a16:creationId xmlns:a16="http://schemas.microsoft.com/office/drawing/2014/main" id="{C2FE768E-682E-DED8-69B2-3B9D71C8A915}"/>
+              </a:ext>
+            </a:extLst>
+          </p:cNvPr>
+          <p:cNvSpPr>
+            <a:spLocks noGrp="1"/>
+          </p:cNvSpPr>
+          <p:nvPr>
+            <p:ph type="sldNum" sz="quarter" idx="12"/>
+          </p:nvPr>
+        </p:nvSpPr>
+        <p:spPr/>
+        <p:txBody>
+          <a:bodyPr/>
+          <a:lstStyle/>
+          <a:p>
+            <a:fld id="{4F4A9865-8A1B-3947-85F2-6D3624F4EFBD}" type="slidenum">
+              <a:rPr lang="en-US" smtClean="0"/>
+              <a:t>‹#›</a:t>
+            </a:fld>
+            <a:endParaRPr lang="en-US"/>
+          </a:p>
+        </p:txBody>
+      </p:sp>
+    </p:spTree>
+    <p:extLst>
+      <p:ext uri="{BB962C8B-B14F-4D97-AF65-F5344CB8AC3E}">
+        <p14:creationId xmlns:p14="http://schemas.microsoft.com/office/powerpoint/2010/main" val="942235356"/>
+      </p:ext>
+    </p:extLst>
+  </p:cSld>
+  <p:clrMapOvr>
+    <a:masterClrMapping/>
+  </p:clrMapOvr>
+</p:sldLayout>
+</file>
+
+<file path=ppt/slideLayouts/slideLayout16.xml><?xml version="1.0" encoding="utf-8"?>
+<p:sldLayout xmlns:a="http://schemas.openxmlformats.org/drawingml/2006/main" xmlns:r="http://schemas.openxmlformats.org/officeDocument/2006/relationships" xmlns:p="http://schemas.openxmlformats.org/presentationml/2006/main" type="twoTxTwoObj" preserve="1">
+  <p:cSld name="Comparison">
+    <p:spTree>
+      <p:nvGrpSpPr>
+        <p:cNvPr id="1" name=""/>
+        <p:cNvGrpSpPr/>
+        <p:nvPr/>
+      </p:nvGrpSpPr>
+      <p:grpSpPr>
+        <a:xfrm>
+          <a:off x="0" y="0"/>
+          <a:ext cx="0" cy="0"/>
+          <a:chOff x="0" y="0"/>
+          <a:chExt cx="0" cy="0"/>
+        </a:xfrm>
+      </p:grpSpPr>
+      <p:sp>
+        <p:nvSpPr>
+          <p:cNvPr id="2" name="Title 1">
+            <a:extLst>
+              <a:ext uri="{FF2B5EF4-FFF2-40B4-BE49-F238E27FC236}">
+                <a16:creationId xmlns:a16="http://schemas.microsoft.com/office/drawing/2014/main" id="{B8083407-9CF9-258C-0C68-EB35A2FD2B18}"/>
+              </a:ext>
+            </a:extLst>
+          </p:cNvPr>
+          <p:cNvSpPr>
+            <a:spLocks noGrp="1"/>
+          </p:cNvSpPr>
+          <p:nvPr>
+            <p:ph type="title"/>
+          </p:nvPr>
+        </p:nvSpPr>
+        <p:spPr>
+          <a:xfrm>
+            <a:off x="839788" y="365125"/>
+            <a:ext cx="10515600" cy="1325563"/>
+          </a:xfrm>
+        </p:spPr>
+        <p:txBody>
+          <a:bodyPr/>
+          <a:lstStyle/>
+          <a:p>
+            <a:r>
+              <a:rPr lang="en-US"/>
+              <a:t>Click to edit Master title style</a:t>
+            </a:r>
+          </a:p>
+        </p:txBody>
+      </p:sp>
+      <p:sp>
+        <p:nvSpPr>
+          <p:cNvPr id="3" name="Text Placeholder 2">
+            <a:extLst>
+              <a:ext uri="{FF2B5EF4-FFF2-40B4-BE49-F238E27FC236}">
+                <a16:creationId xmlns:a16="http://schemas.microsoft.com/office/drawing/2014/main" id="{E87AB7D2-518D-47A5-4EE3-05743E4141AB}"/>
+              </a:ext>
+            </a:extLst>
+          </p:cNvPr>
+          <p:cNvSpPr>
+            <a:spLocks noGrp="1"/>
+          </p:cNvSpPr>
+          <p:nvPr>
+            <p:ph type="body" idx="1"/>
+          </p:nvPr>
+        </p:nvSpPr>
+        <p:spPr>
+          <a:xfrm>
+            <a:off x="839788" y="1681163"/>
+            <a:ext cx="5157787" cy="823912"/>
+          </a:xfrm>
+        </p:spPr>
+        <p:txBody>
+          <a:bodyPr anchor="b"/>
+          <a:lstStyle>
+            <a:lvl1pPr marL="0" indent="0">
+              <a:buNone/>
+              <a:defRPr sz="2400" b="1"/>
+            </a:lvl1pPr>
+            <a:lvl2pPr marL="457200" indent="0">
+              <a:buNone/>
+              <a:defRPr sz="2000" b="1"/>
+            </a:lvl2pPr>
+            <a:lvl3pPr marL="914400" indent="0">
+              <a:buNone/>
+              <a:defRPr sz="1800" b="1"/>
+            </a:lvl3pPr>
+            <a:lvl4pPr marL="1371600" indent="0">
+              <a:buNone/>
+              <a:defRPr sz="1600" b="1"/>
+            </a:lvl4pPr>
+            <a:lvl5pPr marL="1828800" indent="0">
+              <a:buNone/>
+              <a:defRPr sz="1600" b="1"/>
+            </a:lvl5pPr>
+            <a:lvl6pPr marL="2286000" indent="0">
+              <a:buNone/>
+              <a:defRPr sz="1600" b="1"/>
+            </a:lvl6pPr>
+            <a:lvl7pPr marL="2743200" indent="0">
+              <a:buNone/>
+              <a:defRPr sz="1600" b="1"/>
+            </a:lvl7pPr>
+            <a:lvl8pPr marL="3200400" indent="0">
+              <a:buNone/>
+              <a:defRPr sz="1600" b="1"/>
+            </a:lvl8pPr>
+            <a:lvl9pPr marL="3657600" indent="0">
+              <a:buNone/>
+              <a:defRPr sz="1600" b="1"/>
+            </a:lvl9pPr>
+          </a:lstStyle>
+          <a:p>
+            <a:pPr lvl="0"/>
+            <a:r>
+              <a:rPr lang="en-US"/>
+              <a:t>Click to edit Master text styles</a:t>
+            </a:r>
+          </a:p>
+        </p:txBody>
+      </p:sp>
+      <p:sp>
+        <p:nvSpPr>
+          <p:cNvPr id="4" name="Content Placeholder 3">
+            <a:extLst>
+              <a:ext uri="{FF2B5EF4-FFF2-40B4-BE49-F238E27FC236}">
+                <a16:creationId xmlns:a16="http://schemas.microsoft.com/office/drawing/2014/main" id="{66160F8E-5DE5-0D88-9091-845C23E0908D}"/>
+              </a:ext>
+            </a:extLst>
+          </p:cNvPr>
+          <p:cNvSpPr>
+            <a:spLocks noGrp="1"/>
+          </p:cNvSpPr>
+          <p:nvPr>
+            <p:ph sz="half" idx="2"/>
+          </p:nvPr>
+        </p:nvSpPr>
+        <p:spPr>
+          <a:xfrm>
+            <a:off x="839788" y="2505075"/>
+            <a:ext cx="5157787" cy="3684588"/>
+          </a:xfrm>
+        </p:spPr>
+        <p:txBody>
+          <a:bodyPr/>
+          <a:lstStyle/>
+          <a:p>
+            <a:pPr lvl="0"/>
+            <a:r>
+              <a:rPr lang="en-US"/>
+              <a:t>Click to edit Master text styles</a:t>
+            </a:r>
+          </a:p>
+          <a:p>
+            <a:pPr lvl="1"/>
+            <a:r>
+              <a:rPr lang="en-US"/>
+              <a:t>Second level</a:t>
+            </a:r>
+          </a:p>
+          <a:p>
+            <a:pPr lvl="2"/>
+            <a:r>
+              <a:rPr lang="en-US"/>
+              <a:t>Third level</a:t>
+            </a:r>
+          </a:p>
+          <a:p>
+            <a:pPr lvl="3"/>
+            <a:r>
+              <a:rPr lang="en-US"/>
+              <a:t>Fourth level</a:t>
+            </a:r>
+          </a:p>
+          <a:p>
+            <a:pPr lvl="4"/>
+            <a:r>
+              <a:rPr lang="en-US"/>
+              <a:t>Fifth level</a:t>
+            </a:r>
+          </a:p>
+        </p:txBody>
+      </p:sp>
+      <p:sp>
+        <p:nvSpPr>
+          <p:cNvPr id="5" name="Text Placeholder 4">
+            <a:extLst>
+              <a:ext uri="{FF2B5EF4-FFF2-40B4-BE49-F238E27FC236}">
+                <a16:creationId xmlns:a16="http://schemas.microsoft.com/office/drawing/2014/main" id="{3BAFAA8F-A4B7-6F63-911C-BC8550ADB198}"/>
+              </a:ext>
+            </a:extLst>
+          </p:cNvPr>
+          <p:cNvSpPr>
+            <a:spLocks noGrp="1"/>
+          </p:cNvSpPr>
+          <p:nvPr>
+            <p:ph type="body" sz="quarter" idx="3"/>
+          </p:nvPr>
+        </p:nvSpPr>
+        <p:spPr>
+          <a:xfrm>
+            <a:off x="6172200" y="1681163"/>
+            <a:ext cx="5183188" cy="823912"/>
+          </a:xfrm>
+        </p:spPr>
+        <p:txBody>
+          <a:bodyPr anchor="b"/>
+          <a:lstStyle>
+            <a:lvl1pPr marL="0" indent="0">
+              <a:buNone/>
+              <a:defRPr sz="2400" b="1"/>
+            </a:lvl1pPr>
+            <a:lvl2pPr marL="457200" indent="0">
+              <a:buNone/>
+              <a:defRPr sz="2000" b="1"/>
+            </a:lvl2pPr>
+            <a:lvl3pPr marL="914400" indent="0">
+              <a:buNone/>
+              <a:defRPr sz="1800" b="1"/>
+            </a:lvl3pPr>
+            <a:lvl4pPr marL="1371600" indent="0">
+              <a:buNone/>
+              <a:defRPr sz="1600" b="1"/>
+            </a:lvl4pPr>
+            <a:lvl5pPr marL="1828800" indent="0">
+              <a:buNone/>
+              <a:defRPr sz="1600" b="1"/>
+            </a:lvl5pPr>
+            <a:lvl6pPr marL="2286000" indent="0">
+              <a:buNone/>
+              <a:defRPr sz="1600" b="1"/>
+            </a:lvl6pPr>
+            <a:lvl7pPr marL="2743200" indent="0">
+              <a:buNone/>
+              <a:defRPr sz="1600" b="1"/>
+            </a:lvl7pPr>
+            <a:lvl8pPr marL="3200400" indent="0">
+              <a:buNone/>
+              <a:defRPr sz="1600" b="1"/>
+            </a:lvl8pPr>
+            <a:lvl9pPr marL="3657600" indent="0">
+              <a:buNone/>
+              <a:defRPr sz="1600" b="1"/>
+            </a:lvl9pPr>
+          </a:lstStyle>
+          <a:p>
+            <a:pPr lvl="0"/>
+            <a:r>
+              <a:rPr lang="en-US"/>
+              <a:t>Click to edit Master text styles</a:t>
+            </a:r>
+          </a:p>
+        </p:txBody>
+      </p:sp>
+      <p:sp>
+        <p:nvSpPr>
+          <p:cNvPr id="6" name="Content Placeholder 5">
+            <a:extLst>
+              <a:ext uri="{FF2B5EF4-FFF2-40B4-BE49-F238E27FC236}">
+                <a16:creationId xmlns:a16="http://schemas.microsoft.com/office/drawing/2014/main" id="{F5C120E8-8300-C016-39A5-F899EF878F52}"/>
+              </a:ext>
+            </a:extLst>
+          </p:cNvPr>
+          <p:cNvSpPr>
+            <a:spLocks noGrp="1"/>
+          </p:cNvSpPr>
+          <p:nvPr>
+            <p:ph sz="quarter" idx="4"/>
+          </p:nvPr>
+        </p:nvSpPr>
+        <p:spPr>
+          <a:xfrm>
+            <a:off x="6172200" y="2505075"/>
+            <a:ext cx="5183188" cy="3684588"/>
+          </a:xfrm>
+        </p:spPr>
+        <p:txBody>
+          <a:bodyPr/>
+          <a:lstStyle/>
+          <a:p>
+            <a:pPr lvl="0"/>
+            <a:r>
+              <a:rPr lang="en-US"/>
+              <a:t>Click to edit Master text styles</a:t>
+            </a:r>
+          </a:p>
+          <a:p>
+            <a:pPr lvl="1"/>
+            <a:r>
+              <a:rPr lang="en-US"/>
+              <a:t>Second level</a:t>
+            </a:r>
+          </a:p>
+          <a:p>
+            <a:pPr lvl="2"/>
+            <a:r>
+              <a:rPr lang="en-US"/>
+              <a:t>Third level</a:t>
+            </a:r>
+          </a:p>
+          <a:p>
+            <a:pPr lvl="3"/>
+            <a:r>
+              <a:rPr lang="en-US"/>
+              <a:t>Fourth level</a:t>
+            </a:r>
+          </a:p>
+          <a:p>
+            <a:pPr lvl="4"/>
+            <a:r>
+              <a:rPr lang="en-US"/>
+              <a:t>Fifth level</a:t>
+            </a:r>
+          </a:p>
+        </p:txBody>
+      </p:sp>
+      <p:sp>
+        <p:nvSpPr>
+          <p:cNvPr id="7" name="Date Placeholder 6">
+            <a:extLst>
+              <a:ext uri="{FF2B5EF4-FFF2-40B4-BE49-F238E27FC236}">
+                <a16:creationId xmlns:a16="http://schemas.microsoft.com/office/drawing/2014/main" id="{3459E4A1-45AF-31AF-0A79-0F97E679D5AA}"/>
+              </a:ext>
+            </a:extLst>
+          </p:cNvPr>
+          <p:cNvSpPr>
+            <a:spLocks noGrp="1"/>
+          </p:cNvSpPr>
+          <p:nvPr>
+            <p:ph type="dt" sz="half" idx="10"/>
+          </p:nvPr>
+        </p:nvSpPr>
+        <p:spPr/>
+        <p:txBody>
+          <a:bodyPr/>
+          <a:lstStyle/>
+          <a:p>
+            <a:fld id="{9A7A563D-4F5F-0548-A50D-971717DDA77D}" type="datetimeFigureOut">
+              <a:rPr lang="en-US" smtClean="0"/>
+              <a:t>7/11/26</a:t>
+            </a:fld>
+            <a:endParaRPr lang="en-US"/>
+          </a:p>
+        </p:txBody>
+      </p:sp>
+      <p:sp>
+        <p:nvSpPr>
+          <p:cNvPr id="8" name="Footer Placeholder 7">
+            <a:extLst>
+              <a:ext uri="{FF2B5EF4-FFF2-40B4-BE49-F238E27FC236}">
+                <a16:creationId xmlns:a16="http://schemas.microsoft.com/office/drawing/2014/main" id="{D961CB01-D9F5-8238-ECBC-61B72173A15D}"/>
+              </a:ext>
+            </a:extLst>
+          </p:cNvPr>
+          <p:cNvSpPr>
+            <a:spLocks noGrp="1"/>
+          </p:cNvSpPr>
+          <p:nvPr>
+            <p:ph type="ftr" sz="quarter" idx="11"/>
+          </p:nvPr>
+        </p:nvSpPr>
+        <p:spPr/>
+        <p:txBody>
+          <a:bodyPr/>
+          <a:lstStyle/>
+          <a:p>
+            <a:endParaRPr lang="en-US"/>
+          </a:p>
+        </p:txBody>
+      </p:sp>
+      <p:sp>
+        <p:nvSpPr>
+          <p:cNvPr id="9" name="Slide Number Placeholder 8">
+            <a:extLst>
+              <a:ext uri="{FF2B5EF4-FFF2-40B4-BE49-F238E27FC236}">
+                <a16:creationId xmlns:a16="http://schemas.microsoft.com/office/drawing/2014/main" id="{2EB9021E-DFF5-FA79-A6B6-DBB684E6F6BE}"/>
+              </a:ext>
+            </a:extLst>
+          </p:cNvPr>
+          <p:cNvSpPr>
+            <a:spLocks noGrp="1"/>
+          </p:cNvSpPr>
+          <p:nvPr>
+            <p:ph type="sldNum" sz="quarter" idx="12"/>
+          </p:nvPr>
+        </p:nvSpPr>
+        <p:spPr/>
+        <p:txBody>
+          <a:bodyPr/>
+          <a:lstStyle/>
+          <a:p>
+            <a:fld id="{4F4A9865-8A1B-3947-85F2-6D3624F4EFBD}" type="slidenum">
+              <a:rPr lang="en-US" smtClean="0"/>
+              <a:t>‹#›</a:t>
+            </a:fld>
+            <a:endParaRPr lang="en-US"/>
+          </a:p>
+        </p:txBody>
+      </p:sp>
+    </p:spTree>
+    <p:extLst>
+      <p:ext uri="{BB962C8B-B14F-4D97-AF65-F5344CB8AC3E}">
+        <p14:creationId xmlns:p14="http://schemas.microsoft.com/office/powerpoint/2010/main" val="3317954274"/>
+      </p:ext>
+    </p:extLst>
+  </p:cSld>
+  <p:clrMapOvr>
+    <a:masterClrMapping/>
+  </p:clrMapOvr>
+</p:sldLayout>
+</file>
+
+<file path=ppt/slideLayouts/slideLayout17.xml><?xml version="1.0" encoding="utf-8"?>
+<p:sldLayout xmlns:a="http://schemas.openxmlformats.org/drawingml/2006/main" xmlns:r="http://schemas.openxmlformats.org/officeDocument/2006/relationships" xmlns:p="http://schemas.openxmlformats.org/presentationml/2006/main" type="titleOnly" preserve="1">
+  <p:cSld name="Title Only">
+    <p:spTree>
+      <p:nvGrpSpPr>
+        <p:cNvPr id="1" name=""/>
+        <p:cNvGrpSpPr/>
+        <p:nvPr/>
+      </p:nvGrpSpPr>
+      <p:grpSpPr>
+        <a:xfrm>
+          <a:off x="0" y="0"/>
+          <a:ext cx="0" cy="0"/>
+          <a:chOff x="0" y="0"/>
+          <a:chExt cx="0" cy="0"/>
+        </a:xfrm>
+      </p:grpSpPr>
+      <p:sp>
+        <p:nvSpPr>
+          <p:cNvPr id="2" name="Title 1">
+            <a:extLst>
+              <a:ext uri="{FF2B5EF4-FFF2-40B4-BE49-F238E27FC236}">
+                <a16:creationId xmlns:a16="http://schemas.microsoft.com/office/drawing/2014/main" id="{45220BDA-0954-DDEA-3E4A-8E37272D0072}"/>
+              </a:ext>
+            </a:extLst>
+          </p:cNvPr>
+          <p:cNvSpPr>
+            <a:spLocks noGrp="1"/>
+          </p:cNvSpPr>
+          <p:nvPr>
+            <p:ph type="title"/>
+          </p:nvPr>
+        </p:nvSpPr>
+        <p:spPr/>
+        <p:txBody>
+          <a:bodyPr/>
+          <a:lstStyle/>
+          <a:p>
+            <a:r>
+              <a:rPr lang="en-US"/>
+              <a:t>Click to edit Master title style</a:t>
+            </a:r>
+          </a:p>
+        </p:txBody>
+      </p:sp>
+      <p:sp>
+        <p:nvSpPr>
+          <p:cNvPr id="3" name="Date Placeholder 2">
+            <a:extLst>
+              <a:ext uri="{FF2B5EF4-FFF2-40B4-BE49-F238E27FC236}">
+                <a16:creationId xmlns:a16="http://schemas.microsoft.com/office/drawing/2014/main" id="{DB8DB03A-B36B-2063-3AB3-E91E47B9B089}"/>
+              </a:ext>
+            </a:extLst>
+          </p:cNvPr>
+          <p:cNvSpPr>
+            <a:spLocks noGrp="1"/>
+          </p:cNvSpPr>
+          <p:nvPr>
+            <p:ph type="dt" sz="half" idx="10"/>
+          </p:nvPr>
+        </p:nvSpPr>
+        <p:spPr/>
+        <p:txBody>
+          <a:bodyPr/>
+          <a:lstStyle/>
+          <a:p>
+            <a:fld id="{9A7A563D-4F5F-0548-A50D-971717DDA77D}" type="datetimeFigureOut">
+              <a:rPr lang="en-US" smtClean="0"/>
+              <a:t>7/11/26</a:t>
+            </a:fld>
+            <a:endParaRPr lang="en-US"/>
+          </a:p>
+        </p:txBody>
+      </p:sp>
+      <p:sp>
+        <p:nvSpPr>
+          <p:cNvPr id="4" name="Footer Placeholder 3">
+            <a:extLst>
+              <a:ext uri="{FF2B5EF4-FFF2-40B4-BE49-F238E27FC236}">
+                <a16:creationId xmlns:a16="http://schemas.microsoft.com/office/drawing/2014/main" id="{EF1FFD66-C6E2-AB7A-A2F4-8C74E98F5FE0}"/>
+              </a:ext>
+            </a:extLst>
+          </p:cNvPr>
+          <p:cNvSpPr>
+            <a:spLocks noGrp="1"/>
+          </p:cNvSpPr>
+          <p:nvPr>
+            <p:ph type="ftr" sz="quarter" idx="11"/>
+          </p:nvPr>
+        </p:nvSpPr>
+        <p:spPr/>
+        <p:txBody>
+          <a:bodyPr/>
+          <a:lstStyle/>
+          <a:p>
+            <a:endParaRPr lang="en-US"/>
+          </a:p>
+        </p:txBody>
+      </p:sp>
+      <p:sp>
+        <p:nvSpPr>
+          <p:cNvPr id="5" name="Slide Number Placeholder 4">
+            <a:extLst>
+              <a:ext uri="{FF2B5EF4-FFF2-40B4-BE49-F238E27FC236}">
+                <a16:creationId xmlns:a16="http://schemas.microsoft.com/office/drawing/2014/main" id="{B6A95D48-2219-E556-43E8-3B63255FA770}"/>
+              </a:ext>
+            </a:extLst>
+          </p:cNvPr>
+          <p:cNvSpPr>
+            <a:spLocks noGrp="1"/>
+          </p:cNvSpPr>
+          <p:nvPr>
+            <p:ph type="sldNum" sz="quarter" idx="12"/>
+          </p:nvPr>
+        </p:nvSpPr>
+        <p:spPr/>
+        <p:txBody>
+          <a:bodyPr/>
+          <a:lstStyle/>
+          <a:p>
+            <a:fld id="{4F4A9865-8A1B-3947-85F2-6D3624F4EFBD}" type="slidenum">
+              <a:rPr lang="en-US" smtClean="0"/>
+              <a:t>‹#›</a:t>
+            </a:fld>
+            <a:endParaRPr lang="en-US"/>
+          </a:p>
+        </p:txBody>
+      </p:sp>
+    </p:spTree>
+    <p:extLst>
+      <p:ext uri="{BB962C8B-B14F-4D97-AF65-F5344CB8AC3E}">
+        <p14:creationId xmlns:p14="http://schemas.microsoft.com/office/powerpoint/2010/main" val="3048910015"/>
+      </p:ext>
+    </p:extLst>
+  </p:cSld>
+  <p:clrMapOvr>
+    <a:masterClrMapping/>
+  </p:clrMapOvr>
+</p:sldLayout>
+</file>
+
+<file path=ppt/slideLayouts/slideLayout18.xml><?xml version="1.0" encoding="utf-8"?>
+<p:sldLayout xmlns:a="http://schemas.openxmlformats.org/drawingml/2006/main" xmlns:r="http://schemas.openxmlformats.org/officeDocument/2006/relationships" xmlns:p="http://schemas.openxmlformats.org/presentationml/2006/main" type="blank" preserve="1">
+  <p:cSld name="Blank">
+    <p:spTree>
+      <p:nvGrpSpPr>
+        <p:cNvPr id="1" name=""/>
+        <p:cNvGrpSpPr/>
+        <p:nvPr/>
+      </p:nvGrpSpPr>
+      <p:grpSpPr>
+        <a:xfrm>
+          <a:off x="0" y="0"/>
+          <a:ext cx="0" cy="0"/>
+          <a:chOff x="0" y="0"/>
+          <a:chExt cx="0" cy="0"/>
+        </a:xfrm>
+      </p:grpSpPr>
+      <p:sp>
+        <p:nvSpPr>
+          <p:cNvPr id="2" name="Date Placeholder 1">
+            <a:extLst>
+              <a:ext uri="{FF2B5EF4-FFF2-40B4-BE49-F238E27FC236}">
+                <a16:creationId xmlns:a16="http://schemas.microsoft.com/office/drawing/2014/main" id="{A90C496D-88D1-6240-C6C7-D49DE0065CA1}"/>
+              </a:ext>
+            </a:extLst>
+          </p:cNvPr>
+          <p:cNvSpPr>
+            <a:spLocks noGrp="1"/>
+          </p:cNvSpPr>
+          <p:nvPr>
+            <p:ph type="dt" sz="half" idx="10"/>
+          </p:nvPr>
+        </p:nvSpPr>
+        <p:spPr/>
+        <p:txBody>
+          <a:bodyPr/>
+          <a:lstStyle/>
+          <a:p>
+            <a:fld id="{9A7A563D-4F5F-0548-A50D-971717DDA77D}" type="datetimeFigureOut">
+              <a:rPr lang="en-US" smtClean="0"/>
+              <a:t>7/11/26</a:t>
+            </a:fld>
+            <a:endParaRPr lang="en-US"/>
+          </a:p>
+        </p:txBody>
+      </p:sp>
+      <p:sp>
+        <p:nvSpPr>
+          <p:cNvPr id="3" name="Footer Placeholder 2">
+            <a:extLst>
+              <a:ext uri="{FF2B5EF4-FFF2-40B4-BE49-F238E27FC236}">
+                <a16:creationId xmlns:a16="http://schemas.microsoft.com/office/drawing/2014/main" id="{B3A0ECCF-70ED-8CD2-A720-2E2B0DD7AEDC}"/>
+              </a:ext>
+            </a:extLst>
+          </p:cNvPr>
+          <p:cNvSpPr>
+            <a:spLocks noGrp="1"/>
+          </p:cNvSpPr>
+          <p:nvPr>
+            <p:ph type="ftr" sz="quarter" idx="11"/>
+          </p:nvPr>
+        </p:nvSpPr>
+        <p:spPr/>
+        <p:txBody>
+          <a:bodyPr/>
+          <a:lstStyle/>
+          <a:p>
+            <a:endParaRPr lang="en-US"/>
+          </a:p>
+        </p:txBody>
+      </p:sp>
+      <p:sp>
+        <p:nvSpPr>
+          <p:cNvPr id="4" name="Slide Number Placeholder 3">
+            <a:extLst>
+              <a:ext uri="{FF2B5EF4-FFF2-40B4-BE49-F238E27FC236}">
+                <a16:creationId xmlns:a16="http://schemas.microsoft.com/office/drawing/2014/main" id="{2793A66A-BB93-F33A-BACF-B9B82C9BF519}"/>
+              </a:ext>
+            </a:extLst>
+          </p:cNvPr>
+          <p:cNvSpPr>
+            <a:spLocks noGrp="1"/>
+          </p:cNvSpPr>
+          <p:nvPr>
+            <p:ph type="sldNum" sz="quarter" idx="12"/>
+          </p:nvPr>
+        </p:nvSpPr>
+        <p:spPr/>
+        <p:txBody>
+          <a:bodyPr/>
+          <a:lstStyle/>
+          <a:p>
+            <a:fld id="{4F4A9865-8A1B-3947-85F2-6D3624F4EFBD}" type="slidenum">
+              <a:rPr lang="en-US" smtClean="0"/>
+              <a:t>‹#›</a:t>
+            </a:fld>
+            <a:endParaRPr lang="en-US"/>
+          </a:p>
+        </p:txBody>
+      </p:sp>
+    </p:spTree>
+    <p:extLst>
+      <p:ext uri="{BB962C8B-B14F-4D97-AF65-F5344CB8AC3E}">
+        <p14:creationId xmlns:p14="http://schemas.microsoft.com/office/powerpoint/2010/main" val="2022603416"/>
+      </p:ext>
+    </p:extLst>
+  </p:cSld>
+  <p:clrMapOvr>
+    <a:masterClrMapping/>
+  </p:clrMapOvr>
+</p:sldLayout>
+</file>
+
+<file path=ppt/slideLayouts/slideLayout19.xml><?xml version="1.0" encoding="utf-8"?>
+<p:sldLayout xmlns:a="http://schemas.openxmlformats.org/drawingml/2006/main" xmlns:r="http://schemas.openxmlformats.org/officeDocument/2006/relationships" xmlns:p="http://schemas.openxmlformats.org/presentationml/2006/main" type="objTx" preserve="1">
+  <p:cSld name="Content with Caption">
+    <p:spTree>
+      <p:nvGrpSpPr>
+        <p:cNvPr id="1" name=""/>
+        <p:cNvGrpSpPr/>
+        <p:nvPr/>
+      </p:nvGrpSpPr>
+      <p:grpSpPr>
+        <a:xfrm>
+          <a:off x="0" y="0"/>
+          <a:ext cx="0" cy="0"/>
+          <a:chOff x="0" y="0"/>
+          <a:chExt cx="0" cy="0"/>
+        </a:xfrm>
+      </p:grpSpPr>
+      <p:sp>
+        <p:nvSpPr>
+          <p:cNvPr id="2" name="Title 1">
+            <a:extLst>
+              <a:ext uri="{FF2B5EF4-FFF2-40B4-BE49-F238E27FC236}">
+                <a16:creationId xmlns:a16="http://schemas.microsoft.com/office/drawing/2014/main" id="{2FB285B0-4D6F-D7FA-A69F-C2F28D8DCE83}"/>
+              </a:ext>
+            </a:extLst>
+          </p:cNvPr>
+          <p:cNvSpPr>
+            <a:spLocks noGrp="1"/>
+          </p:cNvSpPr>
+          <p:nvPr>
+            <p:ph type="title"/>
+          </p:nvPr>
+        </p:nvSpPr>
+        <p:spPr>
+          <a:xfrm>
+            <a:off x="839788" y="457200"/>
+            <a:ext cx="3932237" cy="1600200"/>
+          </a:xfrm>
+        </p:spPr>
+        <p:txBody>
+          <a:bodyPr anchor="b"/>
+          <a:lstStyle>
+            <a:lvl1pPr>
+              <a:defRPr sz="3200"/>
+            </a:lvl1pPr>
+          </a:lstStyle>
+          <a:p>
+            <a:r>
+              <a:rPr lang="en-US"/>
+              <a:t>Click to edit Master title style</a:t>
+            </a:r>
+          </a:p>
+        </p:txBody>
+      </p:sp>
+      <p:sp>
+        <p:nvSpPr>
+          <p:cNvPr id="3" name="Content Placeholder 2">
+            <a:extLst>
+              <a:ext uri="{FF2B5EF4-FFF2-40B4-BE49-F238E27FC236}">
+                <a16:creationId xmlns:a16="http://schemas.microsoft.com/office/drawing/2014/main" id="{15FAD8AC-AC51-16C7-8DA7-761A1EED04D3}"/>
+              </a:ext>
+            </a:extLst>
+          </p:cNvPr>
+          <p:cNvSpPr>
+            <a:spLocks noGrp="1"/>
+          </p:cNvSpPr>
+          <p:nvPr>
+            <p:ph idx="1"/>
+          </p:nvPr>
+        </p:nvSpPr>
+        <p:spPr>
+          <a:xfrm>
+            <a:off x="5183188" y="987425"/>
+            <a:ext cx="6172200" cy="4873625"/>
+          </a:xfrm>
+        </p:spPr>
+        <p:txBody>
+          <a:bodyPr/>
+          <a:lstStyle>
+            <a:lvl1pPr>
+              <a:defRPr sz="3200"/>
+            </a:lvl1pPr>
+            <a:lvl2pPr>
+              <a:defRPr sz="2800"/>
+            </a:lvl2pPr>
+            <a:lvl3pPr>
+              <a:defRPr sz="2400"/>
+            </a:lvl3pPr>
+            <a:lvl4pPr>
+              <a:defRPr sz="2000"/>
+            </a:lvl4pPr>
+            <a:lvl5pPr>
+              <a:defRPr sz="2000"/>
+            </a:lvl5pPr>
+            <a:lvl6pPr>
+              <a:defRPr sz="2000"/>
+            </a:lvl6pPr>
+            <a:lvl7pPr>
+              <a:defRPr sz="2000"/>
+            </a:lvl7pPr>
+            <a:lvl8pPr>
+              <a:defRPr sz="2000"/>
+            </a:lvl8pPr>
+            <a:lvl9pPr>
+              <a:defRPr sz="2000"/>
+            </a:lvl9pPr>
+          </a:lstStyle>
+          <a:p>
+            <a:pPr lvl="0"/>
+            <a:r>
+              <a:rPr lang="en-US"/>
+              <a:t>Click to edit Master text styles</a:t>
+            </a:r>
+          </a:p>
+          <a:p>
+            <a:pPr lvl="1"/>
+            <a:r>
+              <a:rPr lang="en-US"/>
+              <a:t>Second level</a:t>
+            </a:r>
+          </a:p>
+          <a:p>
+            <a:pPr lvl="2"/>
+            <a:r>
+              <a:rPr lang="en-US"/>
+              <a:t>Third level</a:t>
+            </a:r>
+          </a:p>
+          <a:p>
+            <a:pPr lvl="3"/>
+            <a:r>
+              <a:rPr lang="en-US"/>
+              <a:t>Fourth level</a:t>
+            </a:r>
+          </a:p>
+          <a:p>
+            <a:pPr lvl="4"/>
+            <a:r>
+              <a:rPr lang="en-US"/>
+              <a:t>Fifth level</a:t>
+            </a:r>
+          </a:p>
+        </p:txBody>
+      </p:sp>
+      <p:sp>
+        <p:nvSpPr>
+          <p:cNvPr id="4" name="Text Placeholder 3">
+            <a:extLst>
+              <a:ext uri="{FF2B5EF4-FFF2-40B4-BE49-F238E27FC236}">
+                <a16:creationId xmlns:a16="http://schemas.microsoft.com/office/drawing/2014/main" id="{E2104E46-CBF5-184D-4B2B-293DA84D9FDC}"/>
+              </a:ext>
+            </a:extLst>
+          </p:cNvPr>
+          <p:cNvSpPr>
+            <a:spLocks noGrp="1"/>
+          </p:cNvSpPr>
+          <p:nvPr>
+            <p:ph type="body" sz="half" idx="2"/>
+          </p:nvPr>
+        </p:nvSpPr>
+        <p:spPr>
+          <a:xfrm>
+            <a:off x="839788" y="2057400"/>
+            <a:ext cx="3932237" cy="3811588"/>
+          </a:xfrm>
+        </p:spPr>
+        <p:txBody>
+          <a:bodyPr/>
+          <a:lstStyle>
+            <a:lvl1pPr marL="0" indent="0">
+              <a:buNone/>
+              <a:defRPr sz="1600"/>
+            </a:lvl1pPr>
+            <a:lvl2pPr marL="457200" indent="0">
+              <a:buNone/>
+              <a:defRPr sz="1400"/>
+            </a:lvl2pPr>
+            <a:lvl3pPr marL="914400" indent="0">
+              <a:buNone/>
+              <a:defRPr sz="1200"/>
+            </a:lvl3pPr>
+            <a:lvl4pPr marL="1371600" indent="0">
+              <a:buNone/>
+              <a:defRPr sz="1000"/>
+            </a:lvl4pPr>
+            <a:lvl5pPr marL="1828800" indent="0">
+              <a:buNone/>
+              <a:defRPr sz="1000"/>
+            </a:lvl5pPr>
+            <a:lvl6pPr marL="2286000" indent="0">
+              <a:buNone/>
+              <a:defRPr sz="1000"/>
+            </a:lvl6pPr>
+            <a:lvl7pPr marL="2743200" indent="0">
+              <a:buNone/>
+              <a:defRPr sz="1000"/>
+            </a:lvl7pPr>
+            <a:lvl8pPr marL="3200400" indent="0">
+              <a:buNone/>
+              <a:defRPr sz="1000"/>
+            </a:lvl8pPr>
+            <a:lvl9pPr marL="3657600" indent="0">
+              <a:buNone/>
+              <a:defRPr sz="1000"/>
+            </a:lvl9pPr>
+          </a:lstStyle>
+          <a:p>
+            <a:pPr lvl="0"/>
+            <a:r>
+              <a:rPr lang="en-US"/>
+              <a:t>Click to edit Master text styles</a:t>
+            </a:r>
+          </a:p>
+        </p:txBody>
+      </p:sp>
+      <p:sp>
+        <p:nvSpPr>
+          <p:cNvPr id="5" name="Date Placeholder 4">
+            <a:extLst>
+              <a:ext uri="{FF2B5EF4-FFF2-40B4-BE49-F238E27FC236}">
+                <a16:creationId xmlns:a16="http://schemas.microsoft.com/office/drawing/2014/main" id="{24391A27-4558-806C-16BB-83A2F10C2F15}"/>
+              </a:ext>
+            </a:extLst>
+          </p:cNvPr>
+          <p:cNvSpPr>
+            <a:spLocks noGrp="1"/>
+          </p:cNvSpPr>
+          <p:nvPr>
+            <p:ph type="dt" sz="half" idx="10"/>
+          </p:nvPr>
+        </p:nvSpPr>
+        <p:spPr/>
+        <p:txBody>
+          <a:bodyPr/>
+          <a:lstStyle/>
+          <a:p>
+            <a:fld id="{9A7A563D-4F5F-0548-A50D-971717DDA77D}" type="datetimeFigureOut">
+              <a:rPr lang="en-US" smtClean="0"/>
+              <a:t>7/11/26</a:t>
+            </a:fld>
+            <a:endParaRPr lang="en-US"/>
+          </a:p>
+        </p:txBody>
+      </p:sp>
+      <p:sp>
+        <p:nvSpPr>
+          <p:cNvPr id="6" name="Footer Placeholder 5">
+            <a:extLst>
+              <a:ext uri="{FF2B5EF4-FFF2-40B4-BE49-F238E27FC236}">
+                <a16:creationId xmlns:a16="http://schemas.microsoft.com/office/drawing/2014/main" id="{9161B480-98DC-9271-E25A-37FDC1D400BF}"/>
+              </a:ext>
+            </a:extLst>
+          </p:cNvPr>
+          <p:cNvSpPr>
+            <a:spLocks noGrp="1"/>
+          </p:cNvSpPr>
+          <p:nvPr>
+            <p:ph type="ftr" sz="quarter" idx="11"/>
+          </p:nvPr>
+        </p:nvSpPr>
+        <p:spPr/>
+        <p:txBody>
+          <a:bodyPr/>
+          <a:lstStyle/>
+          <a:p>
+            <a:endParaRPr lang="en-US"/>
+          </a:p>
+        </p:txBody>
+      </p:sp>
+      <p:sp>
+        <p:nvSpPr>
+          <p:cNvPr id="7" name="Slide Number Placeholder 6">
+            <a:extLst>
+              <a:ext uri="{FF2B5EF4-FFF2-40B4-BE49-F238E27FC236}">
+                <a16:creationId xmlns:a16="http://schemas.microsoft.com/office/drawing/2014/main" id="{E7222484-566F-CBF5-89EE-A95A34E3CAFD}"/>
+              </a:ext>
+            </a:extLst>
+          </p:cNvPr>
+          <p:cNvSpPr>
+            <a:spLocks noGrp="1"/>
+          </p:cNvSpPr>
+          <p:nvPr>
+            <p:ph type="sldNum" sz="quarter" idx="12"/>
+          </p:nvPr>
+        </p:nvSpPr>
+        <p:spPr/>
+        <p:txBody>
+          <a:bodyPr/>
+          <a:lstStyle/>
+          <a:p>
+            <a:fld id="{4F4A9865-8A1B-3947-85F2-6D3624F4EFBD}" type="slidenum">
+              <a:rPr lang="en-US" smtClean="0"/>
+              <a:t>‹#›</a:t>
+            </a:fld>
+            <a:endParaRPr lang="en-US"/>
+          </a:p>
+        </p:txBody>
+      </p:sp>
+    </p:spTree>
+    <p:extLst>
+      <p:ext uri="{BB962C8B-B14F-4D97-AF65-F5344CB8AC3E}">
+        <p14:creationId xmlns:p14="http://schemas.microsoft.com/office/powerpoint/2010/main" val="3431492042"/>
       </p:ext>
     </p:extLst>
   </p:cSld>
@@ -865,7 +2801,7 @@
           <a:p>
             <a:fld id="{8F5F7886-6B74-6349-BE53-F5BA7B8ADE1D}" type="datetimeFigureOut">
               <a:rPr lang="en-US" smtClean="0"/>
-              <a:t>7/2/26</a:t>
+              <a:t>7/11/26</a:t>
             </a:fld>
             <a:endParaRPr lang="en-US"/>
           </a:p>
@@ -929,6 +2865,700 @@
     <p:extLst>
       <p:ext uri="{BB962C8B-B14F-4D97-AF65-F5344CB8AC3E}">
         <p14:creationId xmlns:p14="http://schemas.microsoft.com/office/powerpoint/2010/main" val="965294681"/>
+      </p:ext>
+    </p:extLst>
+  </p:cSld>
+  <p:clrMapOvr>
+    <a:masterClrMapping/>
+  </p:clrMapOvr>
+</p:sldLayout>
+</file>
+
+<file path=ppt/slideLayouts/slideLayout20.xml><?xml version="1.0" encoding="utf-8"?>
+<p:sldLayout xmlns:a="http://schemas.openxmlformats.org/drawingml/2006/main" xmlns:r="http://schemas.openxmlformats.org/officeDocument/2006/relationships" xmlns:p="http://schemas.openxmlformats.org/presentationml/2006/main" type="picTx" preserve="1">
+  <p:cSld name="Picture with Caption">
+    <p:spTree>
+      <p:nvGrpSpPr>
+        <p:cNvPr id="1" name=""/>
+        <p:cNvGrpSpPr/>
+        <p:nvPr/>
+      </p:nvGrpSpPr>
+      <p:grpSpPr>
+        <a:xfrm>
+          <a:off x="0" y="0"/>
+          <a:ext cx="0" cy="0"/>
+          <a:chOff x="0" y="0"/>
+          <a:chExt cx="0" cy="0"/>
+        </a:xfrm>
+      </p:grpSpPr>
+      <p:sp>
+        <p:nvSpPr>
+          <p:cNvPr id="2" name="Title 1">
+            <a:extLst>
+              <a:ext uri="{FF2B5EF4-FFF2-40B4-BE49-F238E27FC236}">
+                <a16:creationId xmlns:a16="http://schemas.microsoft.com/office/drawing/2014/main" id="{7E125F4F-D56A-8B33-F291-46F6B87D05E7}"/>
+              </a:ext>
+            </a:extLst>
+          </p:cNvPr>
+          <p:cNvSpPr>
+            <a:spLocks noGrp="1"/>
+          </p:cNvSpPr>
+          <p:nvPr>
+            <p:ph type="title"/>
+          </p:nvPr>
+        </p:nvSpPr>
+        <p:spPr>
+          <a:xfrm>
+            <a:off x="839788" y="457200"/>
+            <a:ext cx="3932237" cy="1600200"/>
+          </a:xfrm>
+        </p:spPr>
+        <p:txBody>
+          <a:bodyPr anchor="b"/>
+          <a:lstStyle>
+            <a:lvl1pPr>
+              <a:defRPr sz="3200"/>
+            </a:lvl1pPr>
+          </a:lstStyle>
+          <a:p>
+            <a:r>
+              <a:rPr lang="en-US"/>
+              <a:t>Click to edit Master title style</a:t>
+            </a:r>
+          </a:p>
+        </p:txBody>
+      </p:sp>
+      <p:sp>
+        <p:nvSpPr>
+          <p:cNvPr id="3" name="Picture Placeholder 2">
+            <a:extLst>
+              <a:ext uri="{FF2B5EF4-FFF2-40B4-BE49-F238E27FC236}">
+                <a16:creationId xmlns:a16="http://schemas.microsoft.com/office/drawing/2014/main" id="{5E00FA7B-2892-8DD7-67F8-DCF05102929B}"/>
+              </a:ext>
+            </a:extLst>
+          </p:cNvPr>
+          <p:cNvSpPr>
+            <a:spLocks noGrp="1"/>
+          </p:cNvSpPr>
+          <p:nvPr>
+            <p:ph type="pic" idx="1"/>
+          </p:nvPr>
+        </p:nvSpPr>
+        <p:spPr>
+          <a:xfrm>
+            <a:off x="5183188" y="987425"/>
+            <a:ext cx="6172200" cy="4873625"/>
+          </a:xfrm>
+        </p:spPr>
+        <p:txBody>
+          <a:bodyPr/>
+          <a:lstStyle>
+            <a:lvl1pPr marL="0" indent="0">
+              <a:buNone/>
+              <a:defRPr sz="3200"/>
+            </a:lvl1pPr>
+            <a:lvl2pPr marL="457200" indent="0">
+              <a:buNone/>
+              <a:defRPr sz="2800"/>
+            </a:lvl2pPr>
+            <a:lvl3pPr marL="914400" indent="0">
+              <a:buNone/>
+              <a:defRPr sz="2400"/>
+            </a:lvl3pPr>
+            <a:lvl4pPr marL="1371600" indent="0">
+              <a:buNone/>
+              <a:defRPr sz="2000"/>
+            </a:lvl4pPr>
+            <a:lvl5pPr marL="1828800" indent="0">
+              <a:buNone/>
+              <a:defRPr sz="2000"/>
+            </a:lvl5pPr>
+            <a:lvl6pPr marL="2286000" indent="0">
+              <a:buNone/>
+              <a:defRPr sz="2000"/>
+            </a:lvl6pPr>
+            <a:lvl7pPr marL="2743200" indent="0">
+              <a:buNone/>
+              <a:defRPr sz="2000"/>
+            </a:lvl7pPr>
+            <a:lvl8pPr marL="3200400" indent="0">
+              <a:buNone/>
+              <a:defRPr sz="2000"/>
+            </a:lvl8pPr>
+            <a:lvl9pPr marL="3657600" indent="0">
+              <a:buNone/>
+              <a:defRPr sz="2000"/>
+            </a:lvl9pPr>
+          </a:lstStyle>
+          <a:p>
+            <a:endParaRPr lang="en-US"/>
+          </a:p>
+        </p:txBody>
+      </p:sp>
+      <p:sp>
+        <p:nvSpPr>
+          <p:cNvPr id="4" name="Text Placeholder 3">
+            <a:extLst>
+              <a:ext uri="{FF2B5EF4-FFF2-40B4-BE49-F238E27FC236}">
+                <a16:creationId xmlns:a16="http://schemas.microsoft.com/office/drawing/2014/main" id="{0A3819C6-D937-657D-FA5E-F36FD68D045F}"/>
+              </a:ext>
+            </a:extLst>
+          </p:cNvPr>
+          <p:cNvSpPr>
+            <a:spLocks noGrp="1"/>
+          </p:cNvSpPr>
+          <p:nvPr>
+            <p:ph type="body" sz="half" idx="2"/>
+          </p:nvPr>
+        </p:nvSpPr>
+        <p:spPr>
+          <a:xfrm>
+            <a:off x="839788" y="2057400"/>
+            <a:ext cx="3932237" cy="3811588"/>
+          </a:xfrm>
+        </p:spPr>
+        <p:txBody>
+          <a:bodyPr/>
+          <a:lstStyle>
+            <a:lvl1pPr marL="0" indent="0">
+              <a:buNone/>
+              <a:defRPr sz="1600"/>
+            </a:lvl1pPr>
+            <a:lvl2pPr marL="457200" indent="0">
+              <a:buNone/>
+              <a:defRPr sz="1400"/>
+            </a:lvl2pPr>
+            <a:lvl3pPr marL="914400" indent="0">
+              <a:buNone/>
+              <a:defRPr sz="1200"/>
+            </a:lvl3pPr>
+            <a:lvl4pPr marL="1371600" indent="0">
+              <a:buNone/>
+              <a:defRPr sz="1000"/>
+            </a:lvl4pPr>
+            <a:lvl5pPr marL="1828800" indent="0">
+              <a:buNone/>
+              <a:defRPr sz="1000"/>
+            </a:lvl5pPr>
+            <a:lvl6pPr marL="2286000" indent="0">
+              <a:buNone/>
+              <a:defRPr sz="1000"/>
+            </a:lvl6pPr>
+            <a:lvl7pPr marL="2743200" indent="0">
+              <a:buNone/>
+              <a:defRPr sz="1000"/>
+            </a:lvl7pPr>
+            <a:lvl8pPr marL="3200400" indent="0">
+              <a:buNone/>
+              <a:defRPr sz="1000"/>
+            </a:lvl8pPr>
+            <a:lvl9pPr marL="3657600" indent="0">
+              <a:buNone/>
+              <a:defRPr sz="1000"/>
+            </a:lvl9pPr>
+          </a:lstStyle>
+          <a:p>
+            <a:pPr lvl="0"/>
+            <a:r>
+              <a:rPr lang="en-US"/>
+              <a:t>Click to edit Master text styles</a:t>
+            </a:r>
+          </a:p>
+        </p:txBody>
+      </p:sp>
+      <p:sp>
+        <p:nvSpPr>
+          <p:cNvPr id="5" name="Date Placeholder 4">
+            <a:extLst>
+              <a:ext uri="{FF2B5EF4-FFF2-40B4-BE49-F238E27FC236}">
+                <a16:creationId xmlns:a16="http://schemas.microsoft.com/office/drawing/2014/main" id="{5CFF2EA3-D8D9-415B-4D07-8CF4EF03D771}"/>
+              </a:ext>
+            </a:extLst>
+          </p:cNvPr>
+          <p:cNvSpPr>
+            <a:spLocks noGrp="1"/>
+          </p:cNvSpPr>
+          <p:nvPr>
+            <p:ph type="dt" sz="half" idx="10"/>
+          </p:nvPr>
+        </p:nvSpPr>
+        <p:spPr/>
+        <p:txBody>
+          <a:bodyPr/>
+          <a:lstStyle/>
+          <a:p>
+            <a:fld id="{9A7A563D-4F5F-0548-A50D-971717DDA77D}" type="datetimeFigureOut">
+              <a:rPr lang="en-US" smtClean="0"/>
+              <a:t>7/11/26</a:t>
+            </a:fld>
+            <a:endParaRPr lang="en-US"/>
+          </a:p>
+        </p:txBody>
+      </p:sp>
+      <p:sp>
+        <p:nvSpPr>
+          <p:cNvPr id="6" name="Footer Placeholder 5">
+            <a:extLst>
+              <a:ext uri="{FF2B5EF4-FFF2-40B4-BE49-F238E27FC236}">
+                <a16:creationId xmlns:a16="http://schemas.microsoft.com/office/drawing/2014/main" id="{29A3844F-568B-B436-3809-45C7671887C5}"/>
+              </a:ext>
+            </a:extLst>
+          </p:cNvPr>
+          <p:cNvSpPr>
+            <a:spLocks noGrp="1"/>
+          </p:cNvSpPr>
+          <p:nvPr>
+            <p:ph type="ftr" sz="quarter" idx="11"/>
+          </p:nvPr>
+        </p:nvSpPr>
+        <p:spPr/>
+        <p:txBody>
+          <a:bodyPr/>
+          <a:lstStyle/>
+          <a:p>
+            <a:endParaRPr lang="en-US"/>
+          </a:p>
+        </p:txBody>
+      </p:sp>
+      <p:sp>
+        <p:nvSpPr>
+          <p:cNvPr id="7" name="Slide Number Placeholder 6">
+            <a:extLst>
+              <a:ext uri="{FF2B5EF4-FFF2-40B4-BE49-F238E27FC236}">
+                <a16:creationId xmlns:a16="http://schemas.microsoft.com/office/drawing/2014/main" id="{07CCA4E4-D459-EAF4-11CA-CD815BFD7D97}"/>
+              </a:ext>
+            </a:extLst>
+          </p:cNvPr>
+          <p:cNvSpPr>
+            <a:spLocks noGrp="1"/>
+          </p:cNvSpPr>
+          <p:nvPr>
+            <p:ph type="sldNum" sz="quarter" idx="12"/>
+          </p:nvPr>
+        </p:nvSpPr>
+        <p:spPr/>
+        <p:txBody>
+          <a:bodyPr/>
+          <a:lstStyle/>
+          <a:p>
+            <a:fld id="{4F4A9865-8A1B-3947-85F2-6D3624F4EFBD}" type="slidenum">
+              <a:rPr lang="en-US" smtClean="0"/>
+              <a:t>‹#›</a:t>
+            </a:fld>
+            <a:endParaRPr lang="en-US"/>
+          </a:p>
+        </p:txBody>
+      </p:sp>
+    </p:spTree>
+    <p:extLst>
+      <p:ext uri="{BB962C8B-B14F-4D97-AF65-F5344CB8AC3E}">
+        <p14:creationId xmlns:p14="http://schemas.microsoft.com/office/powerpoint/2010/main" val="1847530707"/>
+      </p:ext>
+    </p:extLst>
+  </p:cSld>
+  <p:clrMapOvr>
+    <a:masterClrMapping/>
+  </p:clrMapOvr>
+</p:sldLayout>
+</file>
+
+<file path=ppt/slideLayouts/slideLayout21.xml><?xml version="1.0" encoding="utf-8"?>
+<p:sldLayout xmlns:a="http://schemas.openxmlformats.org/drawingml/2006/main" xmlns:r="http://schemas.openxmlformats.org/officeDocument/2006/relationships" xmlns:p="http://schemas.openxmlformats.org/presentationml/2006/main" type="vertTx" preserve="1">
+  <p:cSld name="Title and Vertical Text">
+    <p:spTree>
+      <p:nvGrpSpPr>
+        <p:cNvPr id="1" name=""/>
+        <p:cNvGrpSpPr/>
+        <p:nvPr/>
+      </p:nvGrpSpPr>
+      <p:grpSpPr>
+        <a:xfrm>
+          <a:off x="0" y="0"/>
+          <a:ext cx="0" cy="0"/>
+          <a:chOff x="0" y="0"/>
+          <a:chExt cx="0" cy="0"/>
+        </a:xfrm>
+      </p:grpSpPr>
+      <p:sp>
+        <p:nvSpPr>
+          <p:cNvPr id="2" name="Title 1">
+            <a:extLst>
+              <a:ext uri="{FF2B5EF4-FFF2-40B4-BE49-F238E27FC236}">
+                <a16:creationId xmlns:a16="http://schemas.microsoft.com/office/drawing/2014/main" id="{770CF531-915E-E5D2-F356-A4ACB9645950}"/>
+              </a:ext>
+            </a:extLst>
+          </p:cNvPr>
+          <p:cNvSpPr>
+            <a:spLocks noGrp="1"/>
+          </p:cNvSpPr>
+          <p:nvPr>
+            <p:ph type="title"/>
+          </p:nvPr>
+        </p:nvSpPr>
+        <p:spPr/>
+        <p:txBody>
+          <a:bodyPr/>
+          <a:lstStyle/>
+          <a:p>
+            <a:r>
+              <a:rPr lang="en-US"/>
+              <a:t>Click to edit Master title style</a:t>
+            </a:r>
+          </a:p>
+        </p:txBody>
+      </p:sp>
+      <p:sp>
+        <p:nvSpPr>
+          <p:cNvPr id="3" name="Vertical Text Placeholder 2">
+            <a:extLst>
+              <a:ext uri="{FF2B5EF4-FFF2-40B4-BE49-F238E27FC236}">
+                <a16:creationId xmlns:a16="http://schemas.microsoft.com/office/drawing/2014/main" id="{A33E3D1B-6C20-1626-8B8D-1E4406728C52}"/>
+              </a:ext>
+            </a:extLst>
+          </p:cNvPr>
+          <p:cNvSpPr>
+            <a:spLocks noGrp="1"/>
+          </p:cNvSpPr>
+          <p:nvPr>
+            <p:ph type="body" orient="vert" idx="1"/>
+          </p:nvPr>
+        </p:nvSpPr>
+        <p:spPr/>
+        <p:txBody>
+          <a:bodyPr vert="eaVert"/>
+          <a:lstStyle/>
+          <a:p>
+            <a:pPr lvl="0"/>
+            <a:r>
+              <a:rPr lang="en-US"/>
+              <a:t>Click to edit Master text styles</a:t>
+            </a:r>
+          </a:p>
+          <a:p>
+            <a:pPr lvl="1"/>
+            <a:r>
+              <a:rPr lang="en-US"/>
+              <a:t>Second level</a:t>
+            </a:r>
+          </a:p>
+          <a:p>
+            <a:pPr lvl="2"/>
+            <a:r>
+              <a:rPr lang="en-US"/>
+              <a:t>Third level</a:t>
+            </a:r>
+          </a:p>
+          <a:p>
+            <a:pPr lvl="3"/>
+            <a:r>
+              <a:rPr lang="en-US"/>
+              <a:t>Fourth level</a:t>
+            </a:r>
+          </a:p>
+          <a:p>
+            <a:pPr lvl="4"/>
+            <a:r>
+              <a:rPr lang="en-US"/>
+              <a:t>Fifth level</a:t>
+            </a:r>
+          </a:p>
+        </p:txBody>
+      </p:sp>
+      <p:sp>
+        <p:nvSpPr>
+          <p:cNvPr id="4" name="Date Placeholder 3">
+            <a:extLst>
+              <a:ext uri="{FF2B5EF4-FFF2-40B4-BE49-F238E27FC236}">
+                <a16:creationId xmlns:a16="http://schemas.microsoft.com/office/drawing/2014/main" id="{E2662503-74F8-910A-F342-924B39C3B5EC}"/>
+              </a:ext>
+            </a:extLst>
+          </p:cNvPr>
+          <p:cNvSpPr>
+            <a:spLocks noGrp="1"/>
+          </p:cNvSpPr>
+          <p:nvPr>
+            <p:ph type="dt" sz="half" idx="10"/>
+          </p:nvPr>
+        </p:nvSpPr>
+        <p:spPr/>
+        <p:txBody>
+          <a:bodyPr/>
+          <a:lstStyle/>
+          <a:p>
+            <a:fld id="{9A7A563D-4F5F-0548-A50D-971717DDA77D}" type="datetimeFigureOut">
+              <a:rPr lang="en-US" smtClean="0"/>
+              <a:t>7/11/26</a:t>
+            </a:fld>
+            <a:endParaRPr lang="en-US"/>
+          </a:p>
+        </p:txBody>
+      </p:sp>
+      <p:sp>
+        <p:nvSpPr>
+          <p:cNvPr id="5" name="Footer Placeholder 4">
+            <a:extLst>
+              <a:ext uri="{FF2B5EF4-FFF2-40B4-BE49-F238E27FC236}">
+                <a16:creationId xmlns:a16="http://schemas.microsoft.com/office/drawing/2014/main" id="{50BE0E70-C973-5DB2-CEA5-AA4523B848A6}"/>
+              </a:ext>
+            </a:extLst>
+          </p:cNvPr>
+          <p:cNvSpPr>
+            <a:spLocks noGrp="1"/>
+          </p:cNvSpPr>
+          <p:nvPr>
+            <p:ph type="ftr" sz="quarter" idx="11"/>
+          </p:nvPr>
+        </p:nvSpPr>
+        <p:spPr/>
+        <p:txBody>
+          <a:bodyPr/>
+          <a:lstStyle/>
+          <a:p>
+            <a:endParaRPr lang="en-US"/>
+          </a:p>
+        </p:txBody>
+      </p:sp>
+      <p:sp>
+        <p:nvSpPr>
+          <p:cNvPr id="6" name="Slide Number Placeholder 5">
+            <a:extLst>
+              <a:ext uri="{FF2B5EF4-FFF2-40B4-BE49-F238E27FC236}">
+                <a16:creationId xmlns:a16="http://schemas.microsoft.com/office/drawing/2014/main" id="{1BCF3B31-5BDA-CAC0-E5D1-EFD39E37CEF6}"/>
+              </a:ext>
+            </a:extLst>
+          </p:cNvPr>
+          <p:cNvSpPr>
+            <a:spLocks noGrp="1"/>
+          </p:cNvSpPr>
+          <p:nvPr>
+            <p:ph type="sldNum" sz="quarter" idx="12"/>
+          </p:nvPr>
+        </p:nvSpPr>
+        <p:spPr/>
+        <p:txBody>
+          <a:bodyPr/>
+          <a:lstStyle/>
+          <a:p>
+            <a:fld id="{4F4A9865-8A1B-3947-85F2-6D3624F4EFBD}" type="slidenum">
+              <a:rPr lang="en-US" smtClean="0"/>
+              <a:t>‹#›</a:t>
+            </a:fld>
+            <a:endParaRPr lang="en-US"/>
+          </a:p>
+        </p:txBody>
+      </p:sp>
+    </p:spTree>
+    <p:extLst>
+      <p:ext uri="{BB962C8B-B14F-4D97-AF65-F5344CB8AC3E}">
+        <p14:creationId xmlns:p14="http://schemas.microsoft.com/office/powerpoint/2010/main" val="672218761"/>
+      </p:ext>
+    </p:extLst>
+  </p:cSld>
+  <p:clrMapOvr>
+    <a:masterClrMapping/>
+  </p:clrMapOvr>
+</p:sldLayout>
+</file>
+
+<file path=ppt/slideLayouts/slideLayout22.xml><?xml version="1.0" encoding="utf-8"?>
+<p:sldLayout xmlns:a="http://schemas.openxmlformats.org/drawingml/2006/main" xmlns:r="http://schemas.openxmlformats.org/officeDocument/2006/relationships" xmlns:p="http://schemas.openxmlformats.org/presentationml/2006/main" type="vertTitleAndTx" preserve="1">
+  <p:cSld name="Vertical Title and Text">
+    <p:spTree>
+      <p:nvGrpSpPr>
+        <p:cNvPr id="1" name=""/>
+        <p:cNvGrpSpPr/>
+        <p:nvPr/>
+      </p:nvGrpSpPr>
+      <p:grpSpPr>
+        <a:xfrm>
+          <a:off x="0" y="0"/>
+          <a:ext cx="0" cy="0"/>
+          <a:chOff x="0" y="0"/>
+          <a:chExt cx="0" cy="0"/>
+        </a:xfrm>
+      </p:grpSpPr>
+      <p:sp>
+        <p:nvSpPr>
+          <p:cNvPr id="2" name="Vertical Title 1">
+            <a:extLst>
+              <a:ext uri="{FF2B5EF4-FFF2-40B4-BE49-F238E27FC236}">
+                <a16:creationId xmlns:a16="http://schemas.microsoft.com/office/drawing/2014/main" id="{CCAE3162-212A-8D1C-5F54-53CB9DDB086B}"/>
+              </a:ext>
+            </a:extLst>
+          </p:cNvPr>
+          <p:cNvSpPr>
+            <a:spLocks noGrp="1"/>
+          </p:cNvSpPr>
+          <p:nvPr>
+            <p:ph type="title" orient="vert"/>
+          </p:nvPr>
+        </p:nvSpPr>
+        <p:spPr>
+          <a:xfrm>
+            <a:off x="8724900" y="365125"/>
+            <a:ext cx="2628900" cy="5811838"/>
+          </a:xfrm>
+        </p:spPr>
+        <p:txBody>
+          <a:bodyPr vert="eaVert"/>
+          <a:lstStyle/>
+          <a:p>
+            <a:r>
+              <a:rPr lang="en-US"/>
+              <a:t>Click to edit Master title style</a:t>
+            </a:r>
+          </a:p>
+        </p:txBody>
+      </p:sp>
+      <p:sp>
+        <p:nvSpPr>
+          <p:cNvPr id="3" name="Vertical Text Placeholder 2">
+            <a:extLst>
+              <a:ext uri="{FF2B5EF4-FFF2-40B4-BE49-F238E27FC236}">
+                <a16:creationId xmlns:a16="http://schemas.microsoft.com/office/drawing/2014/main" id="{729E9040-E4A2-FFDA-8F9B-8C007E20EE6D}"/>
+              </a:ext>
+            </a:extLst>
+          </p:cNvPr>
+          <p:cNvSpPr>
+            <a:spLocks noGrp="1"/>
+          </p:cNvSpPr>
+          <p:nvPr>
+            <p:ph type="body" orient="vert" idx="1"/>
+          </p:nvPr>
+        </p:nvSpPr>
+        <p:spPr>
+          <a:xfrm>
+            <a:off x="838200" y="365125"/>
+            <a:ext cx="7734300" cy="5811838"/>
+          </a:xfrm>
+        </p:spPr>
+        <p:txBody>
+          <a:bodyPr vert="eaVert"/>
+          <a:lstStyle/>
+          <a:p>
+            <a:pPr lvl="0"/>
+            <a:r>
+              <a:rPr lang="en-US"/>
+              <a:t>Click to edit Master text styles</a:t>
+            </a:r>
+          </a:p>
+          <a:p>
+            <a:pPr lvl="1"/>
+            <a:r>
+              <a:rPr lang="en-US"/>
+              <a:t>Second level</a:t>
+            </a:r>
+          </a:p>
+          <a:p>
+            <a:pPr lvl="2"/>
+            <a:r>
+              <a:rPr lang="en-US"/>
+              <a:t>Third level</a:t>
+            </a:r>
+          </a:p>
+          <a:p>
+            <a:pPr lvl="3"/>
+            <a:r>
+              <a:rPr lang="en-US"/>
+              <a:t>Fourth level</a:t>
+            </a:r>
+          </a:p>
+          <a:p>
+            <a:pPr lvl="4"/>
+            <a:r>
+              <a:rPr lang="en-US"/>
+              <a:t>Fifth level</a:t>
+            </a:r>
+          </a:p>
+        </p:txBody>
+      </p:sp>
+      <p:sp>
+        <p:nvSpPr>
+          <p:cNvPr id="4" name="Date Placeholder 3">
+            <a:extLst>
+              <a:ext uri="{FF2B5EF4-FFF2-40B4-BE49-F238E27FC236}">
+                <a16:creationId xmlns:a16="http://schemas.microsoft.com/office/drawing/2014/main" id="{B9E8B6CA-D3A3-81E2-CDEB-6338B0A6C2F9}"/>
+              </a:ext>
+            </a:extLst>
+          </p:cNvPr>
+          <p:cNvSpPr>
+            <a:spLocks noGrp="1"/>
+          </p:cNvSpPr>
+          <p:nvPr>
+            <p:ph type="dt" sz="half" idx="10"/>
+          </p:nvPr>
+        </p:nvSpPr>
+        <p:spPr/>
+        <p:txBody>
+          <a:bodyPr/>
+          <a:lstStyle/>
+          <a:p>
+            <a:fld id="{9A7A563D-4F5F-0548-A50D-971717DDA77D}" type="datetimeFigureOut">
+              <a:rPr lang="en-US" smtClean="0"/>
+              <a:t>7/11/26</a:t>
+            </a:fld>
+            <a:endParaRPr lang="en-US"/>
+          </a:p>
+        </p:txBody>
+      </p:sp>
+      <p:sp>
+        <p:nvSpPr>
+          <p:cNvPr id="5" name="Footer Placeholder 4">
+            <a:extLst>
+              <a:ext uri="{FF2B5EF4-FFF2-40B4-BE49-F238E27FC236}">
+                <a16:creationId xmlns:a16="http://schemas.microsoft.com/office/drawing/2014/main" id="{CD5C0B42-B3B3-55E6-2B48-66DA29CE94D7}"/>
+              </a:ext>
+            </a:extLst>
+          </p:cNvPr>
+          <p:cNvSpPr>
+            <a:spLocks noGrp="1"/>
+          </p:cNvSpPr>
+          <p:nvPr>
+            <p:ph type="ftr" sz="quarter" idx="11"/>
+          </p:nvPr>
+        </p:nvSpPr>
+        <p:spPr/>
+        <p:txBody>
+          <a:bodyPr/>
+          <a:lstStyle/>
+          <a:p>
+            <a:endParaRPr lang="en-US"/>
+          </a:p>
+        </p:txBody>
+      </p:sp>
+      <p:sp>
+        <p:nvSpPr>
+          <p:cNvPr id="6" name="Slide Number Placeholder 5">
+            <a:extLst>
+              <a:ext uri="{FF2B5EF4-FFF2-40B4-BE49-F238E27FC236}">
+                <a16:creationId xmlns:a16="http://schemas.microsoft.com/office/drawing/2014/main" id="{6AB6661F-CCE5-9C33-287B-FBFD8E334242}"/>
+              </a:ext>
+            </a:extLst>
+          </p:cNvPr>
+          <p:cNvSpPr>
+            <a:spLocks noGrp="1"/>
+          </p:cNvSpPr>
+          <p:nvPr>
+            <p:ph type="sldNum" sz="quarter" idx="12"/>
+          </p:nvPr>
+        </p:nvSpPr>
+        <p:spPr/>
+        <p:txBody>
+          <a:bodyPr/>
+          <a:lstStyle/>
+          <a:p>
+            <a:fld id="{4F4A9865-8A1B-3947-85F2-6D3624F4EFBD}" type="slidenum">
+              <a:rPr lang="en-US" smtClean="0"/>
+              <a:t>‹#›</a:t>
+            </a:fld>
+            <a:endParaRPr lang="en-US"/>
+          </a:p>
+        </p:txBody>
+      </p:sp>
+    </p:spTree>
+    <p:extLst>
+      <p:ext uri="{BB962C8B-B14F-4D97-AF65-F5344CB8AC3E}">
+        <p14:creationId xmlns:p14="http://schemas.microsoft.com/office/powerpoint/2010/main" val="1909121025"/>
       </p:ext>
     </p:extLst>
   </p:cSld>
@@ -1140,7 +3770,7 @@
           <a:p>
             <a:fld id="{8F5F7886-6B74-6349-BE53-F5BA7B8ADE1D}" type="datetimeFigureOut">
               <a:rPr lang="en-US" smtClean="0"/>
-              <a:t>7/2/26</a:t>
+              <a:t>7/11/26</a:t>
             </a:fld>
             <a:endParaRPr lang="en-US"/>
           </a:p>
@@ -1405,7 +4035,7 @@
           <a:p>
             <a:fld id="{8F5F7886-6B74-6349-BE53-F5BA7B8ADE1D}" type="datetimeFigureOut">
               <a:rPr lang="en-US" smtClean="0"/>
-              <a:t>7/2/26</a:t>
+              <a:t>7/11/26</a:t>
             </a:fld>
             <a:endParaRPr lang="en-US"/>
           </a:p>
@@ -1817,7 +4447,7 @@
           <a:p>
             <a:fld id="{8F5F7886-6B74-6349-BE53-F5BA7B8ADE1D}" type="datetimeFigureOut">
               <a:rPr lang="en-US" smtClean="0"/>
-              <a:t>7/2/26</a:t>
+              <a:t>7/11/26</a:t>
             </a:fld>
             <a:endParaRPr lang="en-US"/>
           </a:p>
@@ -1958,7 +4588,7 @@
           <a:p>
             <a:fld id="{8F5F7886-6B74-6349-BE53-F5BA7B8ADE1D}" type="datetimeFigureOut">
               <a:rPr lang="en-US" smtClean="0"/>
-              <a:t>7/2/26</a:t>
+              <a:t>7/11/26</a:t>
             </a:fld>
             <a:endParaRPr lang="en-US"/>
           </a:p>
@@ -2071,7 +4701,7 @@
           <a:p>
             <a:fld id="{8F5F7886-6B74-6349-BE53-F5BA7B8ADE1D}" type="datetimeFigureOut">
               <a:rPr lang="en-US" smtClean="0"/>
-              <a:t>7/2/26</a:t>
+              <a:t>7/11/26</a:t>
             </a:fld>
             <a:endParaRPr lang="en-US"/>
           </a:p>
@@ -2382,7 +5012,7 @@
           <a:p>
             <a:fld id="{8F5F7886-6B74-6349-BE53-F5BA7B8ADE1D}" type="datetimeFigureOut">
               <a:rPr lang="en-US" smtClean="0"/>
-              <a:t>7/2/26</a:t>
+              <a:t>7/11/26</a:t>
             </a:fld>
             <a:endParaRPr lang="en-US"/>
           </a:p>
@@ -2670,7 +5300,7 @@
           <a:p>
             <a:fld id="{8F5F7886-6B74-6349-BE53-F5BA7B8ADE1D}" type="datetimeFigureOut">
               <a:rPr lang="en-US" smtClean="0"/>
-              <a:t>7/2/26</a:t>
+              <a:t>7/11/26</a:t>
             </a:fld>
             <a:endParaRPr lang="en-US"/>
           </a:p>
@@ -2911,7 +5541,7 @@
           <a:p>
             <a:fld id="{8F5F7886-6B74-6349-BE53-F5BA7B8ADE1D}" type="datetimeFigureOut">
               <a:rPr lang="en-US" smtClean="0"/>
-              <a:t>7/2/26</a:t>
+              <a:t>7/11/26</a:t>
             </a:fld>
             <a:endParaRPr lang="en-US"/>
           </a:p>
@@ -3027,6 +5657,574 @@
     <p:sldLayoutId id="2147483657" r:id="rId9"/>
     <p:sldLayoutId id="2147483658" r:id="rId10"/>
     <p:sldLayoutId id="2147483659" r:id="rId11"/>
+  </p:sldLayoutIdLst>
+  <p:txStyles>
+    <p:titleStyle>
+      <a:lvl1pPr algn="l" defTabSz="914400" rtl="0" eaLnBrk="1" latinLnBrk="0" hangingPunct="1">
+        <a:lnSpc>
+          <a:spcPct val="90000"/>
+        </a:lnSpc>
+        <a:spcBef>
+          <a:spcPct val="0"/>
+        </a:spcBef>
+        <a:buNone/>
+        <a:defRPr sz="4400" kern="1200">
+          <a:solidFill>
+            <a:schemeClr val="tx1"/>
+          </a:solidFill>
+          <a:latin typeface="+mj-lt"/>
+          <a:ea typeface="+mj-ea"/>
+          <a:cs typeface="+mj-cs"/>
+        </a:defRPr>
+      </a:lvl1pPr>
+    </p:titleStyle>
+    <p:bodyStyle>
+      <a:lvl1pPr marL="228600" indent="-228600" algn="l" defTabSz="914400" rtl="0" eaLnBrk="1" latinLnBrk="0" hangingPunct="1">
+        <a:lnSpc>
+          <a:spcPct val="90000"/>
+        </a:lnSpc>
+        <a:spcBef>
+          <a:spcPts val="1000"/>
+        </a:spcBef>
+        <a:buFont typeface="Arial" panose="020B0604020202020204" pitchFamily="34" charset="0"/>
+        <a:buChar char="•"/>
+        <a:defRPr sz="2800" kern="1200">
+          <a:solidFill>
+            <a:schemeClr val="tx1"/>
+          </a:solidFill>
+          <a:latin typeface="+mn-lt"/>
+          <a:ea typeface="+mn-ea"/>
+          <a:cs typeface="+mn-cs"/>
+        </a:defRPr>
+      </a:lvl1pPr>
+      <a:lvl2pPr marL="685800" indent="-228600" algn="l" defTabSz="914400" rtl="0" eaLnBrk="1" latinLnBrk="0" hangingPunct="1">
+        <a:lnSpc>
+          <a:spcPct val="90000"/>
+        </a:lnSpc>
+        <a:spcBef>
+          <a:spcPts val="500"/>
+        </a:spcBef>
+        <a:buFont typeface="Arial" panose="020B0604020202020204" pitchFamily="34" charset="0"/>
+        <a:buChar char="•"/>
+        <a:defRPr sz="2400" kern="1200">
+          <a:solidFill>
+            <a:schemeClr val="tx1"/>
+          </a:solidFill>
+          <a:latin typeface="+mn-lt"/>
+          <a:ea typeface="+mn-ea"/>
+          <a:cs typeface="+mn-cs"/>
+        </a:defRPr>
+      </a:lvl2pPr>
+      <a:lvl3pPr marL="1143000" indent="-228600" algn="l" defTabSz="914400" rtl="0" eaLnBrk="1" latinLnBrk="0" hangingPunct="1">
+        <a:lnSpc>
+          <a:spcPct val="90000"/>
+        </a:lnSpc>
+        <a:spcBef>
+          <a:spcPts val="500"/>
+        </a:spcBef>
+        <a:buFont typeface="Arial" panose="020B0604020202020204" pitchFamily="34" charset="0"/>
+        <a:buChar char="•"/>
+        <a:defRPr sz="2000" kern="1200">
+          <a:solidFill>
+            <a:schemeClr val="tx1"/>
+          </a:solidFill>
+          <a:latin typeface="+mn-lt"/>
+          <a:ea typeface="+mn-ea"/>
+          <a:cs typeface="+mn-cs"/>
+        </a:defRPr>
+      </a:lvl3pPr>
+      <a:lvl4pPr marL="1600200" indent="-228600" algn="l" defTabSz="914400" rtl="0" eaLnBrk="1" latinLnBrk="0" hangingPunct="1">
+        <a:lnSpc>
+          <a:spcPct val="90000"/>
+        </a:lnSpc>
+        <a:spcBef>
+          <a:spcPts val="500"/>
+        </a:spcBef>
+        <a:buFont typeface="Arial" panose="020B0604020202020204" pitchFamily="34" charset="0"/>
+        <a:buChar char="•"/>
+        <a:defRPr sz="1800" kern="1200">
+          <a:solidFill>
+            <a:schemeClr val="tx1"/>
+          </a:solidFill>
+          <a:latin typeface="+mn-lt"/>
+          <a:ea typeface="+mn-ea"/>
+          <a:cs typeface="+mn-cs"/>
+        </a:defRPr>
+      </a:lvl4pPr>
+      <a:lvl5pPr marL="2057400" indent="-228600" algn="l" defTabSz="914400" rtl="0" eaLnBrk="1" latinLnBrk="0" hangingPunct="1">
+        <a:lnSpc>
+          <a:spcPct val="90000"/>
+        </a:lnSpc>
+        <a:spcBef>
+          <a:spcPts val="500"/>
+        </a:spcBef>
+        <a:buFont typeface="Arial" panose="020B0604020202020204" pitchFamily="34" charset="0"/>
+        <a:buChar char="•"/>
+        <a:defRPr sz="1800" kern="1200">
+          <a:solidFill>
+            <a:schemeClr val="tx1"/>
+          </a:solidFill>
+          <a:latin typeface="+mn-lt"/>
+          <a:ea typeface="+mn-ea"/>
+          <a:cs typeface="+mn-cs"/>
+        </a:defRPr>
+      </a:lvl5pPr>
+      <a:lvl6pPr marL="2514600" indent="-228600" algn="l" defTabSz="914400" rtl="0" eaLnBrk="1" latinLnBrk="0" hangingPunct="1">
+        <a:lnSpc>
+          <a:spcPct val="90000"/>
+        </a:lnSpc>
+        <a:spcBef>
+          <a:spcPts val="500"/>
+        </a:spcBef>
+        <a:buFont typeface="Arial" panose="020B0604020202020204" pitchFamily="34" charset="0"/>
+        <a:buChar char="•"/>
+        <a:defRPr sz="1800" kern="1200">
+          <a:solidFill>
+            <a:schemeClr val="tx1"/>
+          </a:solidFill>
+          <a:latin typeface="+mn-lt"/>
+          <a:ea typeface="+mn-ea"/>
+          <a:cs typeface="+mn-cs"/>
+        </a:defRPr>
+      </a:lvl6pPr>
+      <a:lvl7pPr marL="2971800" indent="-228600" algn="l" defTabSz="914400" rtl="0" eaLnBrk="1" latinLnBrk="0" hangingPunct="1">
+        <a:lnSpc>
+          <a:spcPct val="90000"/>
+        </a:lnSpc>
+        <a:spcBef>
+          <a:spcPts val="500"/>
+        </a:spcBef>
+        <a:buFont typeface="Arial" panose="020B0604020202020204" pitchFamily="34" charset="0"/>
+        <a:buChar char="•"/>
+        <a:defRPr sz="1800" kern="1200">
+          <a:solidFill>
+            <a:schemeClr val="tx1"/>
+          </a:solidFill>
+          <a:latin typeface="+mn-lt"/>
+          <a:ea typeface="+mn-ea"/>
+          <a:cs typeface="+mn-cs"/>
+        </a:defRPr>
+      </a:lvl7pPr>
+      <a:lvl8pPr marL="3429000" indent="-228600" algn="l" defTabSz="914400" rtl="0" eaLnBrk="1" latinLnBrk="0" hangingPunct="1">
+        <a:lnSpc>
+          <a:spcPct val="90000"/>
+        </a:lnSpc>
+        <a:spcBef>
+          <a:spcPts val="500"/>
+        </a:spcBef>
+        <a:buFont typeface="Arial" panose="020B0604020202020204" pitchFamily="34" charset="0"/>
+        <a:buChar char="•"/>
+        <a:defRPr sz="1800" kern="1200">
+          <a:solidFill>
+            <a:schemeClr val="tx1"/>
+          </a:solidFill>
+          <a:latin typeface="+mn-lt"/>
+          <a:ea typeface="+mn-ea"/>
+          <a:cs typeface="+mn-cs"/>
+        </a:defRPr>
+      </a:lvl8pPr>
+      <a:lvl9pPr marL="3886200" indent="-228600" algn="l" defTabSz="914400" rtl="0" eaLnBrk="1" latinLnBrk="0" hangingPunct="1">
+        <a:lnSpc>
+          <a:spcPct val="90000"/>
+        </a:lnSpc>
+        <a:spcBef>
+          <a:spcPts val="500"/>
+        </a:spcBef>
+        <a:buFont typeface="Arial" panose="020B0604020202020204" pitchFamily="34" charset="0"/>
+        <a:buChar char="•"/>
+        <a:defRPr sz="1800" kern="1200">
+          <a:solidFill>
+            <a:schemeClr val="tx1"/>
+          </a:solidFill>
+          <a:latin typeface="+mn-lt"/>
+          <a:ea typeface="+mn-ea"/>
+          <a:cs typeface="+mn-cs"/>
+        </a:defRPr>
+      </a:lvl9pPr>
+    </p:bodyStyle>
+    <p:otherStyle>
+      <a:defPPr>
+        <a:defRPr lang="en-US"/>
+      </a:defPPr>
+      <a:lvl1pPr marL="0" algn="l" defTabSz="914400" rtl="0" eaLnBrk="1" latinLnBrk="0" hangingPunct="1">
+        <a:defRPr sz="1800" kern="1200">
+          <a:solidFill>
+            <a:schemeClr val="tx1"/>
+          </a:solidFill>
+          <a:latin typeface="+mn-lt"/>
+          <a:ea typeface="+mn-ea"/>
+          <a:cs typeface="+mn-cs"/>
+        </a:defRPr>
+      </a:lvl1pPr>
+      <a:lvl2pPr marL="457200" algn="l" defTabSz="914400" rtl="0" eaLnBrk="1" latinLnBrk="0" hangingPunct="1">
+        <a:defRPr sz="1800" kern="1200">
+          <a:solidFill>
+            <a:schemeClr val="tx1"/>
+          </a:solidFill>
+          <a:latin typeface="+mn-lt"/>
+          <a:ea typeface="+mn-ea"/>
+          <a:cs typeface="+mn-cs"/>
+        </a:defRPr>
+      </a:lvl2pPr>
+      <a:lvl3pPr marL="914400" algn="l" defTabSz="914400" rtl="0" eaLnBrk="1" latinLnBrk="0" hangingPunct="1">
+        <a:defRPr sz="1800" kern="1200">
+          <a:solidFill>
+            <a:schemeClr val="tx1"/>
+          </a:solidFill>
+          <a:latin typeface="+mn-lt"/>
+          <a:ea typeface="+mn-ea"/>
+          <a:cs typeface="+mn-cs"/>
+        </a:defRPr>
+      </a:lvl3pPr>
+      <a:lvl4pPr marL="1371600" algn="l" defTabSz="914400" rtl="0" eaLnBrk="1" latinLnBrk="0" hangingPunct="1">
+        <a:defRPr sz="1800" kern="1200">
+          <a:solidFill>
+            <a:schemeClr val="tx1"/>
+          </a:solidFill>
+          <a:latin typeface="+mn-lt"/>
+          <a:ea typeface="+mn-ea"/>
+          <a:cs typeface="+mn-cs"/>
+        </a:defRPr>
+      </a:lvl4pPr>
+      <a:lvl5pPr marL="1828800" algn="l" defTabSz="914400" rtl="0" eaLnBrk="1" latinLnBrk="0" hangingPunct="1">
+        <a:defRPr sz="1800" kern="1200">
+          <a:solidFill>
+            <a:schemeClr val="tx1"/>
+          </a:solidFill>
+          <a:latin typeface="+mn-lt"/>
+          <a:ea typeface="+mn-ea"/>
+          <a:cs typeface="+mn-cs"/>
+        </a:defRPr>
+      </a:lvl5pPr>
+      <a:lvl6pPr marL="2286000" algn="l" defTabSz="914400" rtl="0" eaLnBrk="1" latinLnBrk="0" hangingPunct="1">
+        <a:defRPr sz="1800" kern="1200">
+          <a:solidFill>
+            <a:schemeClr val="tx1"/>
+          </a:solidFill>
+          <a:latin typeface="+mn-lt"/>
+          <a:ea typeface="+mn-ea"/>
+          <a:cs typeface="+mn-cs"/>
+        </a:defRPr>
+      </a:lvl6pPr>
+      <a:lvl7pPr marL="2743200" algn="l" defTabSz="914400" rtl="0" eaLnBrk="1" latinLnBrk="0" hangingPunct="1">
+        <a:defRPr sz="1800" kern="1200">
+          <a:solidFill>
+            <a:schemeClr val="tx1"/>
+          </a:solidFill>
+          <a:latin typeface="+mn-lt"/>
+          <a:ea typeface="+mn-ea"/>
+          <a:cs typeface="+mn-cs"/>
+        </a:defRPr>
+      </a:lvl7pPr>
+      <a:lvl8pPr marL="3200400" algn="l" defTabSz="914400" rtl="0" eaLnBrk="1" latinLnBrk="0" hangingPunct="1">
+        <a:defRPr sz="1800" kern="1200">
+          <a:solidFill>
+            <a:schemeClr val="tx1"/>
+          </a:solidFill>
+          <a:latin typeface="+mn-lt"/>
+          <a:ea typeface="+mn-ea"/>
+          <a:cs typeface="+mn-cs"/>
+        </a:defRPr>
+      </a:lvl8pPr>
+      <a:lvl9pPr marL="3657600" algn="l" defTabSz="914400" rtl="0" eaLnBrk="1" latinLnBrk="0" hangingPunct="1">
+        <a:defRPr sz="1800" kern="1200">
+          <a:solidFill>
+            <a:schemeClr val="tx1"/>
+          </a:solidFill>
+          <a:latin typeface="+mn-lt"/>
+          <a:ea typeface="+mn-ea"/>
+          <a:cs typeface="+mn-cs"/>
+        </a:defRPr>
+      </a:lvl9pPr>
+    </p:otherStyle>
+  </p:txStyles>
+</p:sldMaster>
+</file>
+
+<file path=ppt/slideMasters/slideMaster2.xml><?xml version="1.0" encoding="utf-8"?>
+<p:sldMaster xmlns:a="http://schemas.openxmlformats.org/drawingml/2006/main" xmlns:r="http://schemas.openxmlformats.org/officeDocument/2006/relationships" xmlns:p="http://schemas.openxmlformats.org/presentationml/2006/main" preserve="1">
+  <p:cSld>
+    <p:bg>
+      <p:bgRef idx="1001">
+        <a:schemeClr val="bg1"/>
+      </p:bgRef>
+    </p:bg>
+    <p:spTree>
+      <p:nvGrpSpPr>
+        <p:cNvPr id="1" name=""/>
+        <p:cNvGrpSpPr/>
+        <p:nvPr/>
+      </p:nvGrpSpPr>
+      <p:grpSpPr>
+        <a:xfrm>
+          <a:off x="0" y="0"/>
+          <a:ext cx="0" cy="0"/>
+          <a:chOff x="0" y="0"/>
+          <a:chExt cx="0" cy="0"/>
+        </a:xfrm>
+      </p:grpSpPr>
+      <p:sp>
+        <p:nvSpPr>
+          <p:cNvPr id="2" name="Title Placeholder 1">
+            <a:extLst>
+              <a:ext uri="{FF2B5EF4-FFF2-40B4-BE49-F238E27FC236}">
+                <a16:creationId xmlns:a16="http://schemas.microsoft.com/office/drawing/2014/main" id="{357F197F-013A-DD50-08BF-D4CC0A4BFCEA}"/>
+              </a:ext>
+            </a:extLst>
+          </p:cNvPr>
+          <p:cNvSpPr>
+            <a:spLocks noGrp="1"/>
+          </p:cNvSpPr>
+          <p:nvPr>
+            <p:ph type="title"/>
+          </p:nvPr>
+        </p:nvSpPr>
+        <p:spPr>
+          <a:xfrm>
+            <a:off x="838200" y="365125"/>
+            <a:ext cx="10515600" cy="1325563"/>
+          </a:xfrm>
+          <a:prstGeom prst="rect">
+            <a:avLst/>
+          </a:prstGeom>
+        </p:spPr>
+        <p:txBody>
+          <a:bodyPr vert="horz" lIns="91440" tIns="45720" rIns="91440" bIns="45720" rtlCol="0" anchor="ctr">
+            <a:normAutofit/>
+          </a:bodyPr>
+          <a:lstStyle/>
+          <a:p>
+            <a:r>
+              <a:rPr lang="en-US"/>
+              <a:t>Click to edit Master title style</a:t>
+            </a:r>
+          </a:p>
+        </p:txBody>
+      </p:sp>
+      <p:sp>
+        <p:nvSpPr>
+          <p:cNvPr id="3" name="Text Placeholder 2">
+            <a:extLst>
+              <a:ext uri="{FF2B5EF4-FFF2-40B4-BE49-F238E27FC236}">
+                <a16:creationId xmlns:a16="http://schemas.microsoft.com/office/drawing/2014/main" id="{B007F81B-DD60-978B-48FB-B1D4D4F9F6C0}"/>
+              </a:ext>
+            </a:extLst>
+          </p:cNvPr>
+          <p:cNvSpPr>
+            <a:spLocks noGrp="1"/>
+          </p:cNvSpPr>
+          <p:nvPr>
+            <p:ph type="body" idx="1"/>
+          </p:nvPr>
+        </p:nvSpPr>
+        <p:spPr>
+          <a:xfrm>
+            <a:off x="838200" y="1825625"/>
+            <a:ext cx="10515600" cy="4351338"/>
+          </a:xfrm>
+          <a:prstGeom prst="rect">
+            <a:avLst/>
+          </a:prstGeom>
+        </p:spPr>
+        <p:txBody>
+          <a:bodyPr vert="horz" lIns="91440" tIns="45720" rIns="91440" bIns="45720" rtlCol="0">
+            <a:normAutofit/>
+          </a:bodyPr>
+          <a:lstStyle/>
+          <a:p>
+            <a:pPr lvl="0"/>
+            <a:r>
+              <a:rPr lang="en-US"/>
+              <a:t>Click to edit Master text styles</a:t>
+            </a:r>
+          </a:p>
+          <a:p>
+            <a:pPr lvl="1"/>
+            <a:r>
+              <a:rPr lang="en-US"/>
+              <a:t>Second level</a:t>
+            </a:r>
+          </a:p>
+          <a:p>
+            <a:pPr lvl="2"/>
+            <a:r>
+              <a:rPr lang="en-US"/>
+              <a:t>Third level</a:t>
+            </a:r>
+          </a:p>
+          <a:p>
+            <a:pPr lvl="3"/>
+            <a:r>
+              <a:rPr lang="en-US"/>
+              <a:t>Fourth level</a:t>
+            </a:r>
+          </a:p>
+          <a:p>
+            <a:pPr lvl="4"/>
+            <a:r>
+              <a:rPr lang="en-US"/>
+              <a:t>Fifth level</a:t>
+            </a:r>
+          </a:p>
+        </p:txBody>
+      </p:sp>
+      <p:sp>
+        <p:nvSpPr>
+          <p:cNvPr id="4" name="Date Placeholder 3">
+            <a:extLst>
+              <a:ext uri="{FF2B5EF4-FFF2-40B4-BE49-F238E27FC236}">
+                <a16:creationId xmlns:a16="http://schemas.microsoft.com/office/drawing/2014/main" id="{C1D13192-B64F-8BB5-F451-CAE52A221975}"/>
+              </a:ext>
+            </a:extLst>
+          </p:cNvPr>
+          <p:cNvSpPr>
+            <a:spLocks noGrp="1"/>
+          </p:cNvSpPr>
+          <p:nvPr>
+            <p:ph type="dt" sz="half" idx="2"/>
+          </p:nvPr>
+        </p:nvSpPr>
+        <p:spPr>
+          <a:xfrm>
+            <a:off x="838200" y="6356350"/>
+            <a:ext cx="2743200" cy="365125"/>
+          </a:xfrm>
+          <a:prstGeom prst="rect">
+            <a:avLst/>
+          </a:prstGeom>
+        </p:spPr>
+        <p:txBody>
+          <a:bodyPr vert="horz" lIns="91440" tIns="45720" rIns="91440" bIns="45720" rtlCol="0" anchor="ctr"/>
+          <a:lstStyle>
+            <a:lvl1pPr algn="l">
+              <a:defRPr sz="1200">
+                <a:solidFill>
+                  <a:schemeClr val="tx1">
+                    <a:tint val="82000"/>
+                  </a:schemeClr>
+                </a:solidFill>
+              </a:defRPr>
+            </a:lvl1pPr>
+          </a:lstStyle>
+          <a:p>
+            <a:fld id="{9A7A563D-4F5F-0548-A50D-971717DDA77D}" type="datetimeFigureOut">
+              <a:rPr lang="en-US" smtClean="0"/>
+              <a:t>7/11/26</a:t>
+            </a:fld>
+            <a:endParaRPr lang="en-US"/>
+          </a:p>
+        </p:txBody>
+      </p:sp>
+      <p:sp>
+        <p:nvSpPr>
+          <p:cNvPr id="5" name="Footer Placeholder 4">
+            <a:extLst>
+              <a:ext uri="{FF2B5EF4-FFF2-40B4-BE49-F238E27FC236}">
+                <a16:creationId xmlns:a16="http://schemas.microsoft.com/office/drawing/2014/main" id="{6C5FA2C7-1AE0-BA30-648A-30CBBFFA01D5}"/>
+              </a:ext>
+            </a:extLst>
+          </p:cNvPr>
+          <p:cNvSpPr>
+            <a:spLocks noGrp="1"/>
+          </p:cNvSpPr>
+          <p:nvPr>
+            <p:ph type="ftr" sz="quarter" idx="3"/>
+          </p:nvPr>
+        </p:nvSpPr>
+        <p:spPr>
+          <a:xfrm>
+            <a:off x="4038600" y="6356350"/>
+            <a:ext cx="4114800" cy="365125"/>
+          </a:xfrm>
+          <a:prstGeom prst="rect">
+            <a:avLst/>
+          </a:prstGeom>
+        </p:spPr>
+        <p:txBody>
+          <a:bodyPr vert="horz" lIns="91440" tIns="45720" rIns="91440" bIns="45720" rtlCol="0" anchor="ctr"/>
+          <a:lstStyle>
+            <a:lvl1pPr algn="ctr">
+              <a:defRPr sz="1200">
+                <a:solidFill>
+                  <a:schemeClr val="tx1">
+                    <a:tint val="82000"/>
+                  </a:schemeClr>
+                </a:solidFill>
+              </a:defRPr>
+            </a:lvl1pPr>
+          </a:lstStyle>
+          <a:p>
+            <a:endParaRPr lang="en-US"/>
+          </a:p>
+        </p:txBody>
+      </p:sp>
+      <p:sp>
+        <p:nvSpPr>
+          <p:cNvPr id="6" name="Slide Number Placeholder 5">
+            <a:extLst>
+              <a:ext uri="{FF2B5EF4-FFF2-40B4-BE49-F238E27FC236}">
+                <a16:creationId xmlns:a16="http://schemas.microsoft.com/office/drawing/2014/main" id="{1D5E3EB7-5294-C6FF-3854-2EE3E936AF22}"/>
+              </a:ext>
+            </a:extLst>
+          </p:cNvPr>
+          <p:cNvSpPr>
+            <a:spLocks noGrp="1"/>
+          </p:cNvSpPr>
+          <p:nvPr>
+            <p:ph type="sldNum" sz="quarter" idx="4"/>
+          </p:nvPr>
+        </p:nvSpPr>
+        <p:spPr>
+          <a:xfrm>
+            <a:off x="8610600" y="6356350"/>
+            <a:ext cx="2743200" cy="365125"/>
+          </a:xfrm>
+          <a:prstGeom prst="rect">
+            <a:avLst/>
+          </a:prstGeom>
+        </p:spPr>
+        <p:txBody>
+          <a:bodyPr vert="horz" lIns="91440" tIns="45720" rIns="91440" bIns="45720" rtlCol="0" anchor="ctr"/>
+          <a:lstStyle>
+            <a:lvl1pPr algn="r">
+              <a:defRPr sz="1200">
+                <a:solidFill>
+                  <a:schemeClr val="tx1">
+                    <a:tint val="82000"/>
+                  </a:schemeClr>
+                </a:solidFill>
+              </a:defRPr>
+            </a:lvl1pPr>
+          </a:lstStyle>
+          <a:p>
+            <a:fld id="{4F4A9865-8A1B-3947-85F2-6D3624F4EFBD}" type="slidenum">
+              <a:rPr lang="en-US" smtClean="0"/>
+              <a:t>‹#›</a:t>
+            </a:fld>
+            <a:endParaRPr lang="en-US"/>
+          </a:p>
+        </p:txBody>
+      </p:sp>
+    </p:spTree>
+    <p:extLst>
+      <p:ext uri="{BB962C8B-B14F-4D97-AF65-F5344CB8AC3E}">
+        <p14:creationId xmlns:p14="http://schemas.microsoft.com/office/powerpoint/2010/main" val="3122833466"/>
+      </p:ext>
+    </p:extLst>
+  </p:cSld>
+  <p:clrMap bg1="lt1" tx1="dk1" bg2="lt2" tx2="dk2" accent1="accent1" accent2="accent2" accent3="accent3" accent4="accent4" accent5="accent5" accent6="accent6" hlink="hlink" folHlink="folHlink"/>
+  <p:sldLayoutIdLst>
+    <p:sldLayoutId id="2147483661" r:id="rId1"/>
+    <p:sldLayoutId id="2147483662" r:id="rId2"/>
+    <p:sldLayoutId id="2147483663" r:id="rId3"/>
+    <p:sldLayoutId id="2147483664" r:id="rId4"/>
+    <p:sldLayoutId id="2147483665" r:id="rId5"/>
+    <p:sldLayoutId id="2147483666" r:id="rId6"/>
+    <p:sldLayoutId id="2147483667" r:id="rId7"/>
+    <p:sldLayoutId id="2147483668" r:id="rId8"/>
+    <p:sldLayoutId id="2147483669" r:id="rId9"/>
+    <p:sldLayoutId id="2147483670" r:id="rId10"/>
+    <p:sldLayoutId id="2147483671" r:id="rId11"/>
   </p:sldLayoutIdLst>
   <p:txStyles>
     <p:titleStyle>
@@ -4365,4 +7563,319 @@
     </a:ext>
   </a:extLst>
 </a:theme>
+</file>
+
+<file path=ppt/theme/theme2.xml><?xml version="1.0" encoding="utf-8"?>
+<a:theme xmlns:a="http://schemas.openxmlformats.org/drawingml/2006/main" name="Custom Design">
+  <a:themeElements>
+    <a:clrScheme name="Office">
+      <a:dk1>
+        <a:sysClr val="windowText" lastClr="000000"/>
+      </a:dk1>
+      <a:lt1>
+        <a:sysClr val="window" lastClr="FFFFFF"/>
+      </a:lt1>
+      <a:dk2>
+        <a:srgbClr val="0E2841"/>
+      </a:dk2>
+      <a:lt2>
+        <a:srgbClr val="E8E8E8"/>
+      </a:lt2>
+      <a:accent1>
+        <a:srgbClr val="156082"/>
+      </a:accent1>
+      <a:accent2>
+        <a:srgbClr val="E97132"/>
+      </a:accent2>
+      <a:accent3>
+        <a:srgbClr val="196B24"/>
+      </a:accent3>
+      <a:accent4>
+        <a:srgbClr val="0F9ED5"/>
+      </a:accent4>
+      <a:accent5>
+        <a:srgbClr val="A02B93"/>
+      </a:accent5>
+      <a:accent6>
+        <a:srgbClr val="4EA72E"/>
+      </a:accent6>
+      <a:hlink>
+        <a:srgbClr val="467886"/>
+      </a:hlink>
+      <a:folHlink>
+        <a:srgbClr val="96607D"/>
+      </a:folHlink>
+    </a:clrScheme>
+    <a:fontScheme name="Office">
+      <a:majorFont>
+        <a:latin typeface="Aptos Display" panose="02110004020202020204"/>
+        <a:ea typeface=""/>
+        <a:cs typeface=""/>
+        <a:font script="Jpan" typeface="游ゴシック Light"/>
+        <a:font script="Hang" typeface="맑은 고딕"/>
+        <a:font script="Hans" typeface="等线 Light"/>
+        <a:font script="Hant" typeface="新細明體"/>
+        <a:font script="Arab" typeface="Times New Roman"/>
+        <a:font script="Hebr" typeface="Times New Roman"/>
+        <a:font script="Thai" typeface="Angsana New"/>
+        <a:font script="Ethi" typeface="Nyala"/>
+        <a:font script="Beng" typeface="Vrinda"/>
+        <a:font script="Gujr" typeface="Shruti"/>
+        <a:font script="Khmr" typeface="MoolBoran"/>
+        <a:font script="Knda" typeface="Tunga"/>
+        <a:font script="Guru" typeface="Raavi"/>
+        <a:font script="Cans" typeface="Euphemia"/>
+        <a:font script="Cher" typeface="Plantagenet Cherokee"/>
+        <a:font script="Yiii" typeface="Microsoft Yi Baiti"/>
+        <a:font script="Tibt" typeface="Microsoft Himalaya"/>
+        <a:font script="Thaa" typeface="MV Boli"/>
+        <a:font script="Deva" typeface="Mangal"/>
+        <a:font script="Telu" typeface="Gautami"/>
+        <a:font script="Taml" typeface="Latha"/>
+        <a:font script="Syrc" typeface="Estrangelo Edessa"/>
+        <a:font script="Orya" typeface="Kalinga"/>
+        <a:font script="Mlym" typeface="Kartika"/>
+        <a:font script="Laoo" typeface="DokChampa"/>
+        <a:font script="Sinh" typeface="Iskoola Pota"/>
+        <a:font script="Mong" typeface="Mongolian Baiti"/>
+        <a:font script="Viet" typeface="Times New Roman"/>
+        <a:font script="Uigh" typeface="Microsoft Uighur"/>
+        <a:font script="Geor" typeface="Sylfaen"/>
+        <a:font script="Armn" typeface="Arial"/>
+        <a:font script="Bugi" typeface="Leelawadee UI"/>
+        <a:font script="Bopo" typeface="Microsoft JhengHei"/>
+        <a:font script="Java" typeface="Javanese Text"/>
+        <a:font script="Lisu" typeface="Segoe UI"/>
+        <a:font script="Mymr" typeface="Myanmar Text"/>
+        <a:font script="Nkoo" typeface="Ebrima"/>
+        <a:font script="Olck" typeface="Nirmala UI"/>
+        <a:font script="Osma" typeface="Ebrima"/>
+        <a:font script="Phag" typeface="Phagspa"/>
+        <a:font script="Syrn" typeface="Estrangelo Edessa"/>
+        <a:font script="Syrj" typeface="Estrangelo Edessa"/>
+        <a:font script="Syre" typeface="Estrangelo Edessa"/>
+        <a:font script="Sora" typeface="Nirmala UI"/>
+        <a:font script="Tale" typeface="Microsoft Tai Le"/>
+        <a:font script="Talu" typeface="Microsoft New Tai Lue"/>
+        <a:font script="Tfng" typeface="Ebrima"/>
+      </a:majorFont>
+      <a:minorFont>
+        <a:latin typeface="Aptos" panose="02110004020202020204"/>
+        <a:ea typeface=""/>
+        <a:cs typeface=""/>
+        <a:font script="Jpan" typeface="游ゴシック"/>
+        <a:font script="Hang" typeface="맑은 고딕"/>
+        <a:font script="Hans" typeface="等线"/>
+        <a:font script="Hant" typeface="新細明體"/>
+        <a:font script="Arab" typeface="Arial"/>
+        <a:font script="Hebr" typeface="Arial"/>
+        <a:font script="Thai" typeface="Cordia New"/>
+        <a:font script="Ethi" typeface="Nyala"/>
+        <a:font script="Beng" typeface="Vrinda"/>
+        <a:font script="Gujr" typeface="Shruti"/>
+        <a:font script="Khmr" typeface="DaunPenh"/>
+        <a:font script="Knda" typeface="Tunga"/>
+        <a:font script="Guru" typeface="Raavi"/>
+        <a:font script="Cans" typeface="Euphemia"/>
+        <a:font script="Cher" typeface="Plantagenet Cherokee"/>
+        <a:font script="Yiii" typeface="Microsoft Yi Baiti"/>
+        <a:font script="Tibt" typeface="Microsoft Himalaya"/>
+        <a:font script="Thaa" typeface="MV Boli"/>
+        <a:font script="Deva" typeface="Mangal"/>
+        <a:font script="Telu" typeface="Gautami"/>
+        <a:font script="Taml" typeface="Latha"/>
+        <a:font script="Syrc" typeface="Estrangelo Edessa"/>
+        <a:font script="Orya" typeface="Kalinga"/>
+        <a:font script="Mlym" typeface="Kartika"/>
+        <a:font script="Laoo" typeface="DokChampa"/>
+        <a:font script="Sinh" typeface="Iskoola Pota"/>
+        <a:font script="Mong" typeface="Mongolian Baiti"/>
+        <a:font script="Viet" typeface="Arial"/>
+        <a:font script="Uigh" typeface="Microsoft Uighur"/>
+        <a:font script="Geor" typeface="Sylfaen"/>
+        <a:font script="Armn" typeface="Arial"/>
+        <a:font script="Bugi" typeface="Leelawadee UI"/>
+        <a:font script="Bopo" typeface="Microsoft JhengHei"/>
+        <a:font script="Java" typeface="Javanese Text"/>
+        <a:font script="Lisu" typeface="Segoe UI"/>
+        <a:font script="Mymr" typeface="Myanmar Text"/>
+        <a:font script="Nkoo" typeface="Ebrima"/>
+        <a:font script="Olck" typeface="Nirmala UI"/>
+        <a:font script="Osma" typeface="Ebrima"/>
+        <a:font script="Phag" typeface="Phagspa"/>
+        <a:font script="Syrn" typeface="Estrangelo Edessa"/>
+        <a:font script="Syrj" typeface="Estrangelo Edessa"/>
+        <a:font script="Syre" typeface="Estrangelo Edessa"/>
+        <a:font script="Sora" typeface="Nirmala UI"/>
+        <a:font script="Tale" typeface="Microsoft Tai Le"/>
+        <a:font script="Talu" typeface="Microsoft New Tai Lue"/>
+        <a:font script="Tfng" typeface="Ebrima"/>
+      </a:minorFont>
+    </a:fontScheme>
+    <a:fmtScheme name="Office">
+      <a:fillStyleLst>
+        <a:solidFill>
+          <a:schemeClr val="phClr"/>
+        </a:solidFill>
+        <a:gradFill rotWithShape="1">
+          <a:gsLst>
+            <a:gs pos="0">
+              <a:schemeClr val="phClr">
+                <a:lumMod val="110000"/>
+                <a:satMod val="105000"/>
+                <a:tint val="67000"/>
+              </a:schemeClr>
+            </a:gs>
+            <a:gs pos="50000">
+              <a:schemeClr val="phClr">
+                <a:lumMod val="105000"/>
+                <a:satMod val="103000"/>
+                <a:tint val="73000"/>
+              </a:schemeClr>
+            </a:gs>
+            <a:gs pos="100000">
+              <a:schemeClr val="phClr">
+                <a:lumMod val="105000"/>
+                <a:satMod val="109000"/>
+                <a:tint val="81000"/>
+              </a:schemeClr>
+            </a:gs>
+          </a:gsLst>
+          <a:lin ang="5400000" scaled="0"/>
+        </a:gradFill>
+        <a:gradFill rotWithShape="1">
+          <a:gsLst>
+            <a:gs pos="0">
+              <a:schemeClr val="phClr">
+                <a:satMod val="103000"/>
+                <a:lumMod val="102000"/>
+                <a:tint val="94000"/>
+              </a:schemeClr>
+            </a:gs>
+            <a:gs pos="50000">
+              <a:schemeClr val="phClr">
+                <a:satMod val="110000"/>
+                <a:lumMod val="100000"/>
+                <a:shade val="100000"/>
+              </a:schemeClr>
+            </a:gs>
+            <a:gs pos="100000">
+              <a:schemeClr val="phClr">
+                <a:lumMod val="99000"/>
+                <a:satMod val="120000"/>
+                <a:shade val="78000"/>
+              </a:schemeClr>
+            </a:gs>
+          </a:gsLst>
+          <a:lin ang="5400000" scaled="0"/>
+        </a:gradFill>
+      </a:fillStyleLst>
+      <a:lnStyleLst>
+        <a:ln w="12700" cap="flat" cmpd="sng" algn="ctr">
+          <a:solidFill>
+            <a:schemeClr val="phClr"/>
+          </a:solidFill>
+          <a:prstDash val="solid"/>
+          <a:miter lim="800000"/>
+        </a:ln>
+        <a:ln w="19050" cap="flat" cmpd="sng" algn="ctr">
+          <a:solidFill>
+            <a:schemeClr val="phClr"/>
+          </a:solidFill>
+          <a:prstDash val="solid"/>
+          <a:miter lim="800000"/>
+        </a:ln>
+        <a:ln w="25400" cap="flat" cmpd="sng" algn="ctr">
+          <a:solidFill>
+            <a:schemeClr val="phClr"/>
+          </a:solidFill>
+          <a:prstDash val="solid"/>
+          <a:miter lim="800000"/>
+        </a:ln>
+      </a:lnStyleLst>
+      <a:effectStyleLst>
+        <a:effectStyle>
+          <a:effectLst/>
+        </a:effectStyle>
+        <a:effectStyle>
+          <a:effectLst/>
+        </a:effectStyle>
+        <a:effectStyle>
+          <a:effectLst>
+            <a:outerShdw blurRad="57150" dist="19050" dir="5400000" algn="ctr" rotWithShape="0">
+              <a:srgbClr val="000000">
+                <a:alpha val="63000"/>
+              </a:srgbClr>
+            </a:outerShdw>
+          </a:effectLst>
+        </a:effectStyle>
+      </a:effectStyleLst>
+      <a:bgFillStyleLst>
+        <a:solidFill>
+          <a:schemeClr val="phClr"/>
+        </a:solidFill>
+        <a:solidFill>
+          <a:schemeClr val="phClr">
+            <a:tint val="95000"/>
+            <a:satMod val="170000"/>
+          </a:schemeClr>
+        </a:solidFill>
+        <a:gradFill rotWithShape="1">
+          <a:gsLst>
+            <a:gs pos="0">
+              <a:schemeClr val="phClr">
+                <a:tint val="93000"/>
+                <a:satMod val="150000"/>
+                <a:shade val="98000"/>
+                <a:lumMod val="102000"/>
+              </a:schemeClr>
+            </a:gs>
+            <a:gs pos="50000">
+              <a:schemeClr val="phClr">
+                <a:tint val="98000"/>
+                <a:satMod val="130000"/>
+                <a:shade val="90000"/>
+                <a:lumMod val="103000"/>
+              </a:schemeClr>
+            </a:gs>
+            <a:gs pos="100000">
+              <a:schemeClr val="phClr">
+                <a:shade val="63000"/>
+                <a:satMod val="120000"/>
+              </a:schemeClr>
+            </a:gs>
+          </a:gsLst>
+          <a:lin ang="5400000" scaled="0"/>
+        </a:gradFill>
+      </a:bgFillStyleLst>
+    </a:fmtScheme>
+  </a:themeElements>
+  <a:objectDefaults>
+    <a:lnDef>
+      <a:spPr/>
+      <a:bodyPr/>
+      <a:lstStyle/>
+      <a:style>
+        <a:lnRef idx="2">
+          <a:schemeClr val="accent1"/>
+        </a:lnRef>
+        <a:fillRef idx="0">
+          <a:schemeClr val="accent1"/>
+        </a:fillRef>
+        <a:effectRef idx="1">
+          <a:schemeClr val="accent1"/>
+        </a:effectRef>
+        <a:fontRef idx="minor">
+          <a:schemeClr val="tx1"/>
+        </a:fontRef>
+      </a:style>
+    </a:lnDef>
+  </a:objectDefaults>
+  <a:extraClrSchemeLst/>
+  <a:extLst>
+    <a:ext uri="{05A4C25C-085E-4340-85A3-A5531E510DB2}">
+      <thm15:themeFamily xmlns:thm15="http://schemas.microsoft.com/office/thememl/2012/main" name="Office Theme" id="{2E142A2C-CD16-42D6-873A-C26D2A0506FA}" vid="{1BDDFF52-6CD6-40A5-AB3C-68EB2F1E4D0A}"/>
+    </a:ext>
+  </a:extLst>
+</a:theme>
 </file>
</xml_diff>